<commit_message>
docs: update Vibe Coding deck, add Agentic Engineering, Opening, Vibe Engineering decks
Co-Authored-By: Claude Sonnet 5 <noreply@anthropic.com>
</commit_message>
<xml_diff>
--- a/docs/TCA-Vibe-Coding.pptx
+++ b/docs/TCA-Vibe-Coding.pptx
@@ -5,26 +5,25 @@
     <p:sldMasterId id="2147483648" r:id="rId1"/>
   </p:sldMasterIdLst>
   <p:notesMasterIdLst>
-    <p:notesMasterId r:id="rId19"/>
+    <p:notesMasterId r:id="rId18"/>
   </p:notesMasterIdLst>
   <p:sldIdLst>
     <p:sldId id="256" r:id="rId2"/>
-    <p:sldId id="257" r:id="rId3"/>
-    <p:sldId id="258" r:id="rId4"/>
-    <p:sldId id="259" r:id="rId5"/>
-    <p:sldId id="260" r:id="rId6"/>
-    <p:sldId id="261" r:id="rId7"/>
-    <p:sldId id="262" r:id="rId8"/>
-    <p:sldId id="263" r:id="rId9"/>
-    <p:sldId id="264" r:id="rId10"/>
-    <p:sldId id="265" r:id="rId11"/>
-    <p:sldId id="266" r:id="rId12"/>
-    <p:sldId id="267" r:id="rId13"/>
-    <p:sldId id="268" r:id="rId14"/>
-    <p:sldId id="269" r:id="rId15"/>
-    <p:sldId id="270" r:id="rId16"/>
-    <p:sldId id="271" r:id="rId17"/>
-    <p:sldId id="272" r:id="rId18"/>
+    <p:sldId id="258" r:id="rId3"/>
+    <p:sldId id="259" r:id="rId4"/>
+    <p:sldId id="260" r:id="rId5"/>
+    <p:sldId id="261" r:id="rId6"/>
+    <p:sldId id="262" r:id="rId7"/>
+    <p:sldId id="263" r:id="rId8"/>
+    <p:sldId id="264" r:id="rId9"/>
+    <p:sldId id="265" r:id="rId10"/>
+    <p:sldId id="266" r:id="rId11"/>
+    <p:sldId id="267" r:id="rId12"/>
+    <p:sldId id="268" r:id="rId13"/>
+    <p:sldId id="269" r:id="rId14"/>
+    <p:sldId id="270" r:id="rId15"/>
+    <p:sldId id="271" r:id="rId16"/>
+    <p:sldId id="272" r:id="rId17"/>
   </p:sldIdLst>
   <p:sldSz cx="9144000" cy="5143500" type="screen16x9"/>
   <p:notesSz cx="5143500" cy="9144000"/>
@@ -389,11 +388,11 @@
           <a:p>
             <a:r>
               <a:rPr lang="en-US" dirty="0"/>
-              <a:t>SKILL #3 (2:30). "The cockpit" - not the whole plane, just the dials a pilot actually watches. Lean on the top three (context); move fast on the rest.
-/context (Claude) or /status (Codex): shows what it's holding in its head right now. Context is finite. When answers drift, check this first.
-@path: pins an exact file so it stops guessing which file you mean. Keeps context lean. Identical in both tools.
-/compact: summarise and trim a bloated conversation. /clear or fresh session: wipe the slate for an unrelated task so old context doesn't leak.
-Reassurance: you don't memorise this, you just reach for the dials when it goes vague. That's the difference between flying the tool and being flown by it.</a:t>
+              <a:t>CONTEXT (2:00). Metaphor: context is fuel, with a gauge. Three states.
+Too little: not told enough, so it guesses - wrong file, invented convention, confident nonsense. Fix by pinning with @ and stating the goal.
+Just right: the files that matter are pinned, the task is in view, nothing extra. Live here.
+Too much: long rambling session, old unrelated stuff still in the window, slow and leaking into answers. Fix with /compact, or /clear and start fresh.
+Tie back: the cockpit commands keep the gauge in the green. When an answer goes vague or off-topic, 90% of the time it's context, not intelligence.</a:t>
             </a:r>
           </a:p>
         </p:txBody>
@@ -480,11 +479,10 @@
           <a:p>
             <a:r>
               <a:rPr lang="en-US" dirty="0"/>
-              <a:t>CONTEXT (2:00). Metaphor: context is fuel, with a gauge. Three states.
-Too little: not told enough, so it guesses - wrong file, invented convention, confident nonsense. Fix by pinning with @ and stating the goal.
-Just right: the files that matter are pinned, the task is in view, nothing extra. Live here.
-Too much: long rambling session, old unrelated stuff still in the window, slow and leaking into answers. Fix with /compact, or /clear and start fresh.
-Tie back: the cockpit commands keep the gauge in the green. When an answer goes vague or off-topic, 90% of the time it's context, not intelligence.</a:t>
+              <a:t>SKILL #4 (2:00). Set expectations: it WILL break. The first build won't be perfect. Normal, not failure.
+Wrong instinct (left): open the file, read the trace, start fixing. Two problems - you grabbed the keyboard, and the agent's mental model is now stale because you changed things behind its back. You made it worse.
+Right move (right): treat it like a colleague on a call who can't see your screen. Paste the exact error. Describe the behaviour: "streak shows 3, ticked it, still 3." Describe what you SAW, not what to CHANGE. The moment you say "change line 40" you're micromanaging again.
+You are the eyes; it is the hands. Report what the eyes see.</a:t>
             </a:r>
           </a:p>
         </p:txBody>
@@ -571,10 +569,8 @@
           <a:p>
             <a:r>
               <a:rPr lang="en-US" dirty="0"/>
-              <a:t>SKILL #4 (2:00). Set expectations: it WILL break. The first build won't be perfect. Normal, not failure.
-Wrong instinct (left): open the file, read the trace, start fixing. Two problems - you grabbed the keyboard, and the agent's mental model is now stale because you changed things behind its back. You made it worse.
-Right move (right): treat it like a colleague on a call who can't see your screen. Paste the exact error. Describe the behaviour: "streak shows 3, ticked it, still 3." Describe what you SAW, not what to CHANGE. The moment you say "change line 40" you're micromanaging again.
-You are the eyes; it is the hands. Report what the eyes see.</a:t>
+              <a:t>SKILL #5 (1:00). Fast. You never touched git by hand - you asked, the agent did it. "You just shipped without writing a line."
+Two nets, name both - they'll rely on them in the lab. Small commits = personal undo; a bad turn is one revert away, so you can be brave. Checkpoints = OUR net for the day (known-good tags). Fall behind or make a mess, reset and rejoin. Say it clearly: reaching for a checkpoint is expected and fine. Nobody gets stranded.</a:t>
             </a:r>
           </a:p>
         </p:txBody>
@@ -661,8 +657,11 @@
           <a:p>
             <a:r>
               <a:rPr lang="en-US" dirty="0"/>
-              <a:t>SKILL #5 (1:00). Fast. You never touched git by hand - you asked, the agent did it. "You just shipped without writing a line."
-Two nets, name both - they'll rely on them in the lab. Small commits = personal undo; a bad turn is one revert away, so you can be brave. Checkpoints = OUR net for the day (known-good tags). Fall behind or make a mess, reset and rejoin. Say it clearly: reaching for a checkpoint is expected and fine. Nobody gets stranded.</a:t>
+              <a:t>WHAT CHANGED (2:30). Zoom out - the VP-in-the-room slide, and for anyone who's been away: here's how the ground shifted.
+PLANNING - just covered: from "make it plan, check the steps" to "it plans fine, check it understood the right problem." Anchor, don't re-teach.
+CONTEXT - a year ago windows were small and you pruned constantly to stop it forgetting. Now windows are repo-scale and memory persists. But that made context ENGINEERING the discipline, not an afterthought. Most agent failures in the field now trace to context drift and stale memory, not the model being dim. (If asked for a number: industry write-ups put the majority of enterprise agent failures on context, not capability - directional, not gospel.)
+AGENTS - a year ago it was you and one chat. Now both tools run teams: Codex spins up parallel subagents; Claude Code runs Agent Teams sharing a task list and messaging each other. That's your Section 3 this afternoon - plant it.
+Close line - the through-thread of the whole day: the mechanical part got automated, so the human skill moved UP - intent, context, verification. Same reason the returning engineer isn't behind.</a:t>
             </a:r>
           </a:p>
         </p:txBody>
@@ -749,11 +748,10 @@
           <a:p>
             <a:r>
               <a:rPr lang="en-US" dirty="0"/>
-              <a:t>WHAT CHANGED (2:30). Zoom out - the VP-in-the-room slide, and for anyone who's been away: here's how the ground shifted.
-PLANNING - just covered: from "make it plan, check the steps" to "it plans fine, check it understood the right problem." Anchor, don't re-teach.
-CONTEXT - a year ago windows were small and you pruned constantly to stop it forgetting. Now windows are repo-scale and memory persists. But that made context ENGINEERING the discipline, not an afterthought. Most agent failures in the field now trace to context drift and stale memory, not the model being dim. (If asked for a number: industry write-ups put the majority of enterprise agent failures on context, not capability - directional, not gospel.)
-AGENTS - a year ago it was you and one chat. Now both tools run teams: Codex spins up parallel subagents; Claude Code runs Agent Teams sharing a task list and messaging each other. That's your Section 3 this afternoon - plant it.
-Close line - the through-thread of the whole day: the mechanical part got automated, so the human skill moved UP - intent, context, verification. Same reason the returning engineer isn't behind.</a:t>
+              <a:t>TAKEAWAYS (1:30). Mirror of slide 2, now as outcomes.
+Rusty: the win is confidence. You'll feel the loop, the tools stop being scary, and you'll rediscover that your judgement is the valuable part.
+Confident: the win is restraint. You'll feel the tension of directing, catch your keyboard reflex, and - the surprise - get further by doing less.
+Lab reflection prompts: "Where did you reach for the keyboard, and what happened when you didn't?" "Where did you accept output without reading it - what risk did you take?"</a:t>
             </a:r>
           </a:p>
         </p:txBody>
@@ -840,10 +838,9 @@
           <a:p>
             <a:r>
               <a:rPr lang="en-US" dirty="0"/>
-              <a:t>TAKEAWAYS (1:30). Mirror of slide 2, now as outcomes.
-Rusty: the win is confidence. You'll feel the loop, the tools stop being scary, and you'll rediscover that your judgement is the valuable part.
-Confident: the win is restraint. You'll feel the tension of directing, catch your keyboard reflex, and - the surprise - get further by doing less.
-Lab reflection prompts: "Where did you reach for the keyboard, and what happened when you didn't?" "Where did you accept output without reading it - what risk did you take?"</a:t>
+              <a:t>GOLDEN RULES (1:30). Leave this up while they open terminals. Read briskly - they've heard them all.
+1 Resist the keyboard. 2 Prompt by outcome. 3 Plan review not writing. 4 Report symptoms. 5 Commit small, use checkpoints.
+Then bridge to the close.</a:t>
             </a:r>
           </a:p>
         </p:txBody>
@@ -928,12 +925,7 @@
           <a:bodyPr/>
           <a:lstStyle/>
           <a:p>
-            <a:r>
-              <a:rPr lang="en-US" dirty="0"/>
-              <a:t>GOLDEN RULES (1:30). Leave this up while they open terminals. Read briskly - they've heard them all.
-1 Resist the keyboard. 2 Prompt by outcome. 3 Plan review not writing. 4 Report symptoms. 5 Commit small, use checkpoints.
-Then bridge to the close.</a:t>
-            </a:r>
+            <a:endParaRPr lang="en-US" dirty="0"/>
           </a:p>
         </p:txBody>
       </p:sp>
@@ -955,95 +947,6 @@
             <a:fld id="{F7021451-1387-4CA6-816F-3879F97B5CBC}" type="slidenum">
               <a:rPr lang="en-US"/>
               <a:t>16</a:t>
-            </a:fld>
-            <a:endParaRPr lang="en-US"/>
-          </a:p>
-        </p:txBody>
-      </p:sp>
-    </p:spTree>
-    <p:extLst>
-      <p:ext uri="{BB962C8B-B14F-4D97-AF65-F5344CB8AC3E}">
-        <p14:creationId xmlns:p14="http://schemas.microsoft.com/office/powerpoint/2010/main" val="1024086991"/>
-      </p:ext>
-    </p:extLst>
-  </p:cSld>
-  <p:clrMapOvr>
-    <a:masterClrMapping/>
-  </p:clrMapOvr>
-</p:notes>
-</file>
-
-<file path=ppt/notesSlides/notesSlide17.xml><?xml version="1.0" encoding="utf-8"?>
-<p:notes xmlns:a="http://schemas.openxmlformats.org/drawingml/2006/main" xmlns:r="http://schemas.openxmlformats.org/officeDocument/2006/relationships" xmlns:p="http://schemas.openxmlformats.org/presentationml/2006/main">
-  <p:cSld>
-    <p:spTree>
-      <p:nvGrpSpPr>
-        <p:cNvPr id="1" name=""/>
-        <p:cNvGrpSpPr/>
-        <p:nvPr/>
-      </p:nvGrpSpPr>
-      <p:grpSpPr>
-        <a:xfrm>
-          <a:off x="0" y="0"/>
-          <a:ext cx="0" cy="0"/>
-          <a:chOff x="0" y="0"/>
-          <a:chExt cx="0" cy="0"/>
-        </a:xfrm>
-      </p:grpSpPr>
-      <p:sp>
-        <p:nvSpPr>
-          <p:cNvPr id="2" name="Slide Image Placeholder 1"/>
-          <p:cNvSpPr>
-            <a:spLocks noGrp="1" noRot="1" noChangeAspect="1"/>
-          </p:cNvSpPr>
-          <p:nvPr>
-            <p:ph type="sldImg"/>
-          </p:nvPr>
-        </p:nvSpPr>
-        <p:spPr/>
-      </p:sp>
-      <p:sp>
-        <p:nvSpPr>
-          <p:cNvPr id="3" name="Notes Placeholder 2"/>
-          <p:cNvSpPr>
-            <a:spLocks noGrp="1"/>
-          </p:cNvSpPr>
-          <p:nvPr>
-            <p:ph type="body" idx="1"/>
-          </p:nvPr>
-        </p:nvSpPr>
-        <p:spPr/>
-        <p:txBody>
-          <a:bodyPr/>
-          <a:lstStyle/>
-          <a:p>
-            <a:r>
-              <a:rPr lang="en-US" dirty="0"/>
-              <a:t>CLOSE (1:00). Lift the energy: this morning is the easy, fun rung. By this afternoon you'll run a TEAM of agents that build and test for you. It all starts with the loop you just learned.
-Final line, warm and direct: "You're not behind. The typing got automated; the judgement didn't. Let's build." Hand to the lab - Block A: scaffold from an empty folder, one prompt, plan first.
-Total run ~29-30 min including buffer.</a:t>
-            </a:r>
-          </a:p>
-        </p:txBody>
-      </p:sp>
-      <p:sp>
-        <p:nvSpPr>
-          <p:cNvPr id="4" name="Slide Number Placeholder 3"/>
-          <p:cNvSpPr>
-            <a:spLocks noGrp="1"/>
-          </p:cNvSpPr>
-          <p:nvPr>
-            <p:ph type="sldNum" sz="quarter" idx="10"/>
-          </p:nvPr>
-        </p:nvSpPr>
-        <p:spPr/>
-        <p:txBody>
-          <a:bodyPr/>
-          <a:lstStyle/>
-          <a:p>
-            <a:fld id="{F7021451-1387-4CA6-816F-3879F97B5CBC}" type="slidenum">
-              <a:rPr lang="en-US"/>
-              <a:t>17</a:t>
             </a:fld>
             <a:endParaRPr lang="en-US"/>
           </a:p>
@@ -1108,10 +1011,8 @@
           <a:p>
             <a:r>
               <a:rPr lang="en-US" dirty="0"/>
-              <a:t>FRAMING (1:15). The honesty slide. Name the two halves of the room warmly.
-Rusty engineers: you are NOT behind. The part of the job that decayed - remembering syntax, hand-typing boilerplate - is exactly the part that got automated. Your judgement about what "good" looks like matters more now, not less.
-Confident engineers: fair warning, this is harder for you. Your speed is a habit to unlearn. Today the skill is directing, not doing.
-Land it: "Everyone here learns something new."</a:t>
+              <a:t>THE LADDER (1:15). Each rung removes a different crutch. Rung 1 (now): lean fully on the agent, ugly is fine. Rung 2: make it behave the same tomorrow. Rung 3: stop trusting it, build harnesses.
+The point of the day is the change in your RELATIONSHIP to the code, not the app. This morning: "you drive, I direct." Don't over-explain 2 and 3.</a:t>
             </a:r>
           </a:p>
         </p:txBody>
@@ -1198,8 +1099,8 @@
           <a:p>
             <a:r>
               <a:rPr lang="en-US" dirty="0"/>
-              <a:t>THE LADDER (1:15). Each rung removes a different crutch. Rung 1 (now): lean fully on the agent, ugly is fine. Rung 2: make it behave the same tomorrow. Rung 3: stop trusting it, build harnesses.
-The point of the day is the change in your RELATIONSHIP to the code, not the app. This morning: "you drive, I direct." Don't over-explain 2 and 3.</a:t>
+              <a:t>DEFINITION (1:15). Vibe coding = using the tool. That's the whole definition today.
+The mindset shift is the money line. Read both quotes aloud. Old question = implementation. New question = outcome. All day we push from "how" to "what". For the confident engineers this is the uncomfortable one - you're good at "how".</a:t>
             </a:r>
           </a:p>
         </p:txBody>
@@ -1286,8 +1187,10 @@
           <a:p>
             <a:r>
               <a:rPr lang="en-US" dirty="0"/>
-              <a:t>DEFINITION (1:15). Vibe coding = using the tool. That's the whole definition today.
-The mindset shift is the money line. Read both quotes aloud. Old question = implementation. New question = outcome. All day we push from "how" to "what". For the confident engineers this is the uncomfortable one - you're good at "how".</a:t>
+              <a:t>THE LOOP (2:45 - core slide). Walk left to right. 1 PROMPT you say what you want. 2 GENERATE it writes. 3 RUN it executes/tests. 4 OBSERVE you look at what actually happened. 5 REACT you respond, go again.
+Most important point: your work is 1, 4, 5 - prompt, observe, react. Steps 2 and 3 belong to the agent. Every time you grab the keyboard to do step 2, you break the loop.
+Second point: small turns. Don't ask for the whole app and disappear. Small loop, look, react.
+Ask the room: "Which step do people get wrong most?" (Answer: they skip OBSERVE - accept output without looking.)</a:t>
             </a:r>
           </a:p>
         </p:txBody>
@@ -1374,10 +1277,12 @@
           <a:p>
             <a:r>
               <a:rPr lang="en-US" dirty="0"/>
-              <a:t>THE LOOP (2:45 - core slide). Walk left to right. 1 PROMPT you say what you want. 2 GENERATE it writes. 3 RUN it executes/tests. 4 OBSERVE you look at what actually happened. 5 REACT you respond, go again.
-Most important point: your work is 1, 4, 5 - prompt, observe, react. Steps 2 and 3 belong to the agent. Every time you grab the keyboard to do step 2, you break the loop.
-Second point: small turns. Don't ask for the whole app and disappear. Small loop, look, react.
-Ask the room: "Which step do people get wrong most?" (Answer: they skip OBSERVE - accept output without looking.)</a:t>
+              <a:t>ANATOMY (2:00 - technical grounding). Vocabulary for the juniors, precise model for the seniors.
+CONTEXT WINDOW - the agent's short-term memory: your prompt, open files, the conversation, every command's output. Finite, and it fills up. Nearly every "it went stupid" moment is really "context is full or polluted." Remember this two slides on.
+TOOLS - it doesn't just emit text. It calls tools: read/write a file, run the shell, run tests, git, search, MCP servers. Tools make it an agent, not a chatbot.
+THE LOOP - pick a tool, run it, READ the result, decide, repeat. Same loop as before, machinery visible.
+PERMISSIONS - what it may do without asking. Both tools have approval modes: ask-every-time, ask-for-risky, or full-auto in a sandbox. The most important safety dial; most people never touch it.
+Say it: not autocomplete - it reasons, acts through tools, checks its own results.</a:t>
             </a:r>
           </a:p>
         </p:txBody>
@@ -1464,12 +1369,10 @@
           <a:p>
             <a:r>
               <a:rPr lang="en-US" dirty="0"/>
-              <a:t>ANATOMY (2:00 - technical grounding). Vocabulary for the juniors, precise model for the seniors.
-CONTEXT WINDOW - the agent's short-term memory: your prompt, open files, the conversation, every command's output. Finite, and it fills up. Nearly every "it went stupid" moment is really "context is full or polluted." Remember this two slides on.
-TOOLS - it doesn't just emit text. It calls tools: read/write a file, run the shell, run tests, git, search, MCP servers. Tools make it an agent, not a chatbot.
-THE LOOP - pick a tool, run it, READ the result, decide, repeat. Same loop as before, machinery visible.
-PERMISSIONS - what it may do without asking. Both tools have approval modes: ask-every-time, ask-for-risky, or full-auto in a sandbox. The most important safety dial; most people never touch it.
-Say it: not autocomplete - it reasons, acts through tools, checks its own results.</a:t>
+              <a:t>THE RULE (1:45). Slow down - emotional anchor of the session. Say it plainly, let it sit: "Resist the keyboard."
+Every workshop someone opens the file and hand-edits the moment the agent stumbles. It feels productive; it's the habit we're breaking. The struggle of NOT touching it is the lesson.
+Reframe the twitch: the urge to fix it means you know what's wrong - so say what's wrong in a prompt. You still use your expertise, just in words not keystrokes.
+Lab note: we don't help for the first three minutes of any block. Same principle.</a:t>
             </a:r>
           </a:p>
         </p:txBody>
@@ -1556,10 +1459,10 @@
           <a:p>
             <a:r>
               <a:rPr lang="en-US" dirty="0"/>
-              <a:t>THE RULE (1:45). Slow down - emotional anchor of the session. Say it plainly, let it sit: "Resist the keyboard."
-Every workshop someone opens the file and hand-edits the moment the agent stumbles. It feels productive; it's the habit we're breaking. The struggle of NOT touching it is the lesson.
-Reframe the twitch: the urge to fix it means you know what's wrong - so say what's wrong in a prompt. You still use your expertise, just in words not keystrokes.
-Lab note: we don't help for the first three minutes of any block. Same principle.</a:t>
+              <a:t>SKILL #1 (2:30). Read the left box in a tedious voice - feel how exhausting it is. That's hand-coding through a straw: you did the thinking AND you carry the risk of being wrong.
+Right box: two changes - OUTCOME (streak grows, miss resets) plus a CONSTRAINT ("show me a plan first"). You never named a file or said "how". The agent can choose a better implementation than you'd type.
+The tell you're doing it right: the same prompt works verbatim in Claude Code or Codex. Implementation-free prompts are portable.
+Seniors: you often DO know the best implementation - bank it for OBSERVE and REACT, don't type it. This is the habit they take back to work Monday.</a:t>
             </a:r>
           </a:p>
         </p:txBody>
@@ -1646,10 +1549,12 @@
           <a:p>
             <a:r>
               <a:rPr lang="en-US" dirty="0"/>
-              <a:t>SKILL #1 (2:30). Read the left box in a tedious voice - feel how exhausting it is. That's hand-coding through a straw: you did the thinking AND you carry the risk of being wrong.
-Right box: two changes - OUTCOME (streak grows, miss resets) plus a CONSTRAINT ("show me a plan first"). You never named a file or said "how". The agent can choose a better implementation than you'd type.
-The tell you're doing it right: the same prompt works verbatim in Claude Code or Codex. Implementation-free prompts are portable.
-Seniors: you often DO know the best implementation - bank it for OBSERVE and REACT, don't type it. This is the habit they take back to work Monday.</a:t>
+              <a:t>SKILL #2 (2:30). Lead with the "what changed" - half the room learned the old way.
+A year ago, plan mode was about MECHANICS: you forced a plan because left alone it charged in and made a mess, and you read for dumb structural mistakes. 2025 models genuinely planned clumsily.
+That's mostly over. Modern agents decompose and sequence well. If you're still checking whether it put the loop in the right file, you're auditing a problem it rarely has.
+The risk FLIPPED. The dangerous plan today isn't messy - it's clean, confident, and aimed at slightly the wrong target. A tidy plan for the wrong problem is more dangerous than an obviously bad one - it doesn't trip your alarm.
+So the review moved UP: read for INTENT and SCOPE. Did it get the real goal? Touching more than it should? What did it assume that I never said?
+Confident engineers: a good-looking plan lulls you. Rusty: good news - "is this even the right problem" is exactly your strength, and it's what matters most now. Keys unchanged.</a:t>
             </a:r>
           </a:p>
         </p:txBody>
@@ -1736,12 +1641,11 @@
           <a:p>
             <a:r>
               <a:rPr lang="en-US" dirty="0"/>
-              <a:t>SKILL #2 (2:30). Lead with the "what changed" - half the room learned the old way.
-A year ago, plan mode was about MECHANICS: you forced a plan because left alone it charged in and made a mess, and you read for dumb structural mistakes. 2025 models genuinely planned clumsily.
-That's mostly over. Modern agents decompose and sequence well. If you're still checking whether it put the loop in the right file, you're auditing a problem it rarely has.
-The risk FLIPPED. The dangerous plan today isn't messy - it's clean, confident, and aimed at slightly the wrong target. A tidy plan for the wrong problem is more dangerous than an obviously bad one - it doesn't trip your alarm.
-So the review moved UP: read for INTENT and SCOPE. Did it get the real goal? Touching more than it should? What did it assume that I never said?
-Confident engineers: a good-looking plan lulls you. Rusty: good news - "is this even the right problem" is exactly your strength, and it's what matters most now. Keys unchanged.</a:t>
+              <a:t>SKILL #3 (2:30). "The cockpit" - not the whole plane, just the dials a pilot actually watches. Lean on the top three (context); move fast on the rest.
+/context (Claude) or /status (Codex): shows what it's holding in its head right now. Context is finite. When answers drift, check this first.
+@path: pins an exact file so it stops guessing which file you mean. Keeps context lean. Identical in both tools.
+/compact: summarise and trim a bloated conversation. /clear or fresh session: wipe the slate for an unrelated task so old context doesn't leak.
+Reassurance: you don't memorise this, you just reach for the dials when it goes vague. That's the difference between flying the tool and being flown by it.</a:t>
             </a:r>
           </a:p>
         </p:txBody>
@@ -2482,873 +2386,6 @@
 
 <file path=ppt/slides/slide10.xml><?xml version="1.0" encoding="utf-8"?>
 <p:sld xmlns:a="http://schemas.openxmlformats.org/drawingml/2006/main" xmlns:r="http://schemas.openxmlformats.org/officeDocument/2006/relationships" xmlns:p="http://schemas.openxmlformats.org/presentationml/2006/main">
-  <p:cSld name="Slide 10">
-    <p:bg>
-      <p:bgPr>
-        <a:solidFill>
-          <a:srgbClr val="F5F3FF"/>
-        </a:solidFill>
-        <a:effectLst/>
-      </p:bgPr>
-    </p:bg>
-    <p:spTree>
-      <p:nvGrpSpPr>
-        <p:cNvPr id="1" name=""/>
-        <p:cNvGrpSpPr/>
-        <p:nvPr/>
-      </p:nvGrpSpPr>
-      <p:grpSpPr>
-        <a:xfrm>
-          <a:off x="0" y="0"/>
-          <a:ext cx="0" cy="0"/>
-          <a:chOff x="0" y="0"/>
-          <a:chExt cx="0" cy="0"/>
-        </a:xfrm>
-      </p:grpSpPr>
-      <p:sp>
-        <p:nvSpPr>
-          <p:cNvPr id="2" name="Text 0"/>
-          <p:cNvSpPr/>
-          <p:nvPr/>
-        </p:nvSpPr>
-        <p:spPr>
-          <a:xfrm>
-            <a:off x="457200" y="292608"/>
-            <a:ext cx="8229600" cy="566928"/>
-          </a:xfrm>
-          <a:prstGeom prst="rect">
-            <a:avLst/>
-          </a:prstGeom>
-          <a:noFill/>
-          <a:ln/>
-        </p:spPr>
-        <p:txBody>
-          <a:bodyPr wrap="square" rtlCol="0" anchor="ctr"/>
-          <a:lstStyle/>
-          <a:p>
-            <a:pPr marL="0" indent="0" algn="l">
-              <a:buNone/>
-            </a:pPr>
-            <a:r>
-              <a:rPr lang="en-US" sz="2700" b="1" kern="0" spc="100" dirty="0">
-                <a:solidFill>
-                  <a:srgbClr val="2D1155"/>
-                </a:solidFill>
-                <a:latin typeface="Arial Black" pitchFamily="34" charset="0"/>
-                <a:ea typeface="Arial Black" pitchFamily="34" charset="-122"/>
-                <a:cs typeface="Arial Black" pitchFamily="34" charset="-120"/>
-              </a:rPr>
-              <a:t>THE COCKPIT</a:t>
-            </a:r>
-            <a:endParaRPr lang="en-US" sz="2700" dirty="0"/>
-          </a:p>
-        </p:txBody>
-      </p:sp>
-      <p:sp>
-        <p:nvSpPr>
-          <p:cNvPr id="3" name="Text 1"/>
-          <p:cNvSpPr/>
-          <p:nvPr/>
-        </p:nvSpPr>
-        <p:spPr>
-          <a:xfrm>
-            <a:off x="475488" y="896112"/>
-            <a:ext cx="8229600" cy="329184"/>
-          </a:xfrm>
-          <a:prstGeom prst="rect">
-            <a:avLst/>
-          </a:prstGeom>
-          <a:noFill/>
-          <a:ln/>
-        </p:spPr>
-        <p:txBody>
-          <a:bodyPr wrap="square" rtlCol="0" anchor="ctr"/>
-          <a:lstStyle/>
-          <a:p>
-            <a:pPr marL="0" indent="0">
-              <a:buNone/>
-            </a:pPr>
-            <a:r>
-              <a:rPr lang="en-US" sz="1300" i="1" dirty="0">
-                <a:solidFill>
-                  <a:srgbClr val="6E6389"/>
-                </a:solidFill>
-                <a:latin typeface="Calibri" pitchFamily="34" charset="0"/>
-                <a:ea typeface="Calibri" pitchFamily="34" charset="-122"/>
-                <a:cs typeface="Calibri" pitchFamily="34" charset="-120"/>
-              </a:rPr>
-              <a:t>Skill #3 — the handful of commands that put you in control.</a:t>
-            </a:r>
-            <a:endParaRPr lang="en-US" sz="1300" dirty="0"/>
-          </a:p>
-        </p:txBody>
-      </p:sp>
-      <p:pic>
-        <p:nvPicPr>
-          <p:cNvPr id="4" name="Image 0" descr="logo_icon.jpeg"/>
-          <p:cNvPicPr>
-            <a:picLocks noChangeAspect="1"/>
-          </p:cNvPicPr>
-          <p:nvPr/>
-        </p:nvPicPr>
-        <p:blipFill>
-          <a:blip r:embed="rId3"/>
-          <a:stretch>
-            <a:fillRect/>
-          </a:stretch>
-        </p:blipFill>
-        <p:spPr>
-          <a:xfrm>
-            <a:off x="8366760" y="4526280"/>
-            <a:ext cx="411480" cy="411480"/>
-          </a:xfrm>
-          <a:prstGeom prst="ellipse">
-            <a:avLst/>
-          </a:prstGeom>
-        </p:spPr>
-      </p:pic>
-      <p:sp>
-        <p:nvSpPr>
-          <p:cNvPr id="5" name="Text 2"/>
-          <p:cNvSpPr/>
-          <p:nvPr/>
-        </p:nvSpPr>
-        <p:spPr>
-          <a:xfrm>
-            <a:off x="640080" y="1481328"/>
-            <a:ext cx="2926080" cy="274320"/>
-          </a:xfrm>
-          <a:prstGeom prst="rect">
-            <a:avLst/>
-          </a:prstGeom>
-          <a:noFill/>
-          <a:ln/>
-        </p:spPr>
-        <p:txBody>
-          <a:bodyPr wrap="square" rtlCol="0" anchor="ctr"/>
-          <a:lstStyle/>
-          <a:p>
-            <a:pPr marL="0" indent="0">
-              <a:buNone/>
-            </a:pPr>
-            <a:r>
-              <a:rPr lang="en-US" sz="1000" b="1" kern="0" spc="100" dirty="0">
-                <a:solidFill>
-                  <a:srgbClr val="6E6389"/>
-                </a:solidFill>
-                <a:latin typeface="Calibri" pitchFamily="34" charset="0"/>
-                <a:ea typeface="Calibri" pitchFamily="34" charset="-122"/>
-                <a:cs typeface="Calibri" pitchFamily="34" charset="-120"/>
-              </a:rPr>
-              <a:t>WHAT YOU WANT</a:t>
-            </a:r>
-            <a:endParaRPr lang="en-US" sz="1000" dirty="0"/>
-          </a:p>
-        </p:txBody>
-      </p:sp>
-      <p:sp>
-        <p:nvSpPr>
-          <p:cNvPr id="6" name="Text 3"/>
-          <p:cNvSpPr/>
-          <p:nvPr/>
-        </p:nvSpPr>
-        <p:spPr>
-          <a:xfrm>
-            <a:off x="3749040" y="1481328"/>
-            <a:ext cx="2468880" cy="274320"/>
-          </a:xfrm>
-          <a:prstGeom prst="rect">
-            <a:avLst/>
-          </a:prstGeom>
-          <a:noFill/>
-          <a:ln/>
-        </p:spPr>
-        <p:txBody>
-          <a:bodyPr wrap="square" rtlCol="0" anchor="ctr"/>
-          <a:lstStyle/>
-          <a:p>
-            <a:pPr marL="0" indent="0">
-              <a:buNone/>
-            </a:pPr>
-            <a:r>
-              <a:rPr lang="en-US" sz="1000" b="1" kern="0" spc="100" dirty="0">
-                <a:solidFill>
-                  <a:srgbClr val="F59E0B"/>
-                </a:solidFill>
-                <a:latin typeface="Calibri" pitchFamily="34" charset="0"/>
-                <a:ea typeface="Calibri" pitchFamily="34" charset="-122"/>
-                <a:cs typeface="Calibri" pitchFamily="34" charset="-120"/>
-              </a:rPr>
-              <a:t>CLAUDE CODE</a:t>
-            </a:r>
-            <a:endParaRPr lang="en-US" sz="1000" dirty="0"/>
-          </a:p>
-        </p:txBody>
-      </p:sp>
-      <p:sp>
-        <p:nvSpPr>
-          <p:cNvPr id="7" name="Text 4"/>
-          <p:cNvSpPr/>
-          <p:nvPr/>
-        </p:nvSpPr>
-        <p:spPr>
-          <a:xfrm>
-            <a:off x="6355080" y="1481328"/>
-            <a:ext cx="2286000" cy="274320"/>
-          </a:xfrm>
-          <a:prstGeom prst="rect">
-            <a:avLst/>
-          </a:prstGeom>
-          <a:noFill/>
-          <a:ln/>
-        </p:spPr>
-        <p:txBody>
-          <a:bodyPr wrap="square" rtlCol="0" anchor="ctr"/>
-          <a:lstStyle/>
-          <a:p>
-            <a:pPr marL="0" indent="0">
-              <a:buNone/>
-            </a:pPr>
-            <a:r>
-              <a:rPr lang="en-US" sz="1000" b="1" kern="0" spc="100" dirty="0">
-                <a:solidFill>
-                  <a:srgbClr val="7C3AED"/>
-                </a:solidFill>
-                <a:latin typeface="Calibri" pitchFamily="34" charset="0"/>
-                <a:ea typeface="Calibri" pitchFamily="34" charset="-122"/>
-                <a:cs typeface="Calibri" pitchFamily="34" charset="-120"/>
-              </a:rPr>
-              <a:t>CODEX</a:t>
-            </a:r>
-            <a:endParaRPr lang="en-US" sz="1000" dirty="0"/>
-          </a:p>
-        </p:txBody>
-      </p:sp>
-      <p:sp>
-        <p:nvSpPr>
-          <p:cNvPr id="8" name="Shape 5"/>
-          <p:cNvSpPr/>
-          <p:nvPr/>
-        </p:nvSpPr>
-        <p:spPr>
-          <a:xfrm>
-            <a:off x="457200" y="1810512"/>
-            <a:ext cx="8229600" cy="603504"/>
-          </a:xfrm>
-          <a:prstGeom prst="rect">
-            <a:avLst/>
-          </a:prstGeom>
-          <a:solidFill>
-            <a:srgbClr val="DDD6FE"/>
-          </a:solidFill>
-          <a:ln/>
-        </p:spPr>
-        <p:txBody>
-          <a:bodyPr/>
-          <a:lstStyle/>
-          <a:p>
-            <a:endParaRPr lang="en-AU"/>
-          </a:p>
-        </p:txBody>
-      </p:sp>
-      <p:sp>
-        <p:nvSpPr>
-          <p:cNvPr id="9" name="Text 6"/>
-          <p:cNvSpPr/>
-          <p:nvPr/>
-        </p:nvSpPr>
-        <p:spPr>
-          <a:xfrm>
-            <a:off x="640080" y="1810512"/>
-            <a:ext cx="3017520" cy="603504"/>
-          </a:xfrm>
-          <a:prstGeom prst="rect">
-            <a:avLst/>
-          </a:prstGeom>
-          <a:noFill/>
-          <a:ln/>
-        </p:spPr>
-        <p:txBody>
-          <a:bodyPr wrap="square" rtlCol="0" anchor="ctr"/>
-          <a:lstStyle/>
-          <a:p>
-            <a:pPr marL="0" indent="0">
-              <a:buNone/>
-            </a:pPr>
-            <a:r>
-              <a:rPr lang="en-US" sz="1250" dirty="0">
-                <a:solidFill>
-                  <a:srgbClr val="2D1155"/>
-                </a:solidFill>
-                <a:latin typeface="Calibri" pitchFamily="34" charset="0"/>
-                <a:ea typeface="Calibri" pitchFamily="34" charset="-122"/>
-                <a:cs typeface="Calibri" pitchFamily="34" charset="-120"/>
-              </a:rPr>
-              <a:t>Check what it's carrying</a:t>
-            </a:r>
-            <a:endParaRPr lang="en-US" sz="1250" dirty="0"/>
-          </a:p>
-        </p:txBody>
-      </p:sp>
-      <p:sp>
-        <p:nvSpPr>
-          <p:cNvPr id="10" name="Text 7"/>
-          <p:cNvSpPr/>
-          <p:nvPr/>
-        </p:nvSpPr>
-        <p:spPr>
-          <a:xfrm>
-            <a:off x="3749040" y="1810512"/>
-            <a:ext cx="2560320" cy="603504"/>
-          </a:xfrm>
-          <a:prstGeom prst="rect">
-            <a:avLst/>
-          </a:prstGeom>
-          <a:noFill/>
-          <a:ln/>
-        </p:spPr>
-        <p:txBody>
-          <a:bodyPr wrap="square" rtlCol="0" anchor="ctr"/>
-          <a:lstStyle/>
-          <a:p>
-            <a:pPr marL="0" indent="0">
-              <a:buNone/>
-            </a:pPr>
-            <a:r>
-              <a:rPr lang="en-US" sz="1300" b="1" dirty="0">
-                <a:solidFill>
-                  <a:srgbClr val="5B21B6"/>
-                </a:solidFill>
-                <a:latin typeface="Courier New" pitchFamily="34" charset="0"/>
-                <a:ea typeface="Courier New" pitchFamily="34" charset="-122"/>
-                <a:cs typeface="Courier New" pitchFamily="34" charset="-120"/>
-              </a:rPr>
-              <a:t>/context</a:t>
-            </a:r>
-            <a:endParaRPr lang="en-US" sz="1300" dirty="0"/>
-          </a:p>
-        </p:txBody>
-      </p:sp>
-      <p:sp>
-        <p:nvSpPr>
-          <p:cNvPr id="11" name="Text 8"/>
-          <p:cNvSpPr/>
-          <p:nvPr/>
-        </p:nvSpPr>
-        <p:spPr>
-          <a:xfrm>
-            <a:off x="6355080" y="1810512"/>
-            <a:ext cx="2286000" cy="603504"/>
-          </a:xfrm>
-          <a:prstGeom prst="rect">
-            <a:avLst/>
-          </a:prstGeom>
-          <a:noFill/>
-          <a:ln/>
-        </p:spPr>
-        <p:txBody>
-          <a:bodyPr wrap="square" rtlCol="0" anchor="ctr"/>
-          <a:lstStyle/>
-          <a:p>
-            <a:pPr marL="0" indent="0">
-              <a:buNone/>
-            </a:pPr>
-            <a:r>
-              <a:rPr lang="en-US" sz="1300" b="1" dirty="0">
-                <a:solidFill>
-                  <a:srgbClr val="7C3AED"/>
-                </a:solidFill>
-                <a:latin typeface="Courier New" pitchFamily="34" charset="0"/>
-                <a:ea typeface="Courier New" pitchFamily="34" charset="-122"/>
-                <a:cs typeface="Courier New" pitchFamily="34" charset="-120"/>
-              </a:rPr>
-              <a:t>/status</a:t>
-            </a:r>
-            <a:endParaRPr lang="en-US" sz="1300" dirty="0"/>
-          </a:p>
-        </p:txBody>
-      </p:sp>
-      <p:sp>
-        <p:nvSpPr>
-          <p:cNvPr id="12" name="Shape 9"/>
-          <p:cNvSpPr/>
-          <p:nvPr/>
-        </p:nvSpPr>
-        <p:spPr>
-          <a:xfrm>
-            <a:off x="457200" y="2414016"/>
-            <a:ext cx="8229600" cy="603504"/>
-          </a:xfrm>
-          <a:prstGeom prst="rect">
-            <a:avLst/>
-          </a:prstGeom>
-          <a:solidFill>
-            <a:srgbClr val="FFFFFF"/>
-          </a:solidFill>
-          <a:ln/>
-        </p:spPr>
-        <p:txBody>
-          <a:bodyPr/>
-          <a:lstStyle/>
-          <a:p>
-            <a:endParaRPr lang="en-AU"/>
-          </a:p>
-        </p:txBody>
-      </p:sp>
-      <p:sp>
-        <p:nvSpPr>
-          <p:cNvPr id="13" name="Text 10"/>
-          <p:cNvSpPr/>
-          <p:nvPr/>
-        </p:nvSpPr>
-        <p:spPr>
-          <a:xfrm>
-            <a:off x="640080" y="2414016"/>
-            <a:ext cx="3017520" cy="603504"/>
-          </a:xfrm>
-          <a:prstGeom prst="rect">
-            <a:avLst/>
-          </a:prstGeom>
-          <a:noFill/>
-          <a:ln/>
-        </p:spPr>
-        <p:txBody>
-          <a:bodyPr wrap="square" rtlCol="0" anchor="ctr"/>
-          <a:lstStyle/>
-          <a:p>
-            <a:pPr marL="0" indent="0">
-              <a:buNone/>
-            </a:pPr>
-            <a:r>
-              <a:rPr lang="en-US" sz="1250" dirty="0">
-                <a:solidFill>
-                  <a:srgbClr val="2D1155"/>
-                </a:solidFill>
-                <a:latin typeface="Calibri" pitchFamily="34" charset="0"/>
-                <a:ea typeface="Calibri" pitchFamily="34" charset="-122"/>
-                <a:cs typeface="Calibri" pitchFamily="34" charset="-120"/>
-              </a:rPr>
-              <a:t>Pin a file into context</a:t>
-            </a:r>
-            <a:endParaRPr lang="en-US" sz="1250" dirty="0"/>
-          </a:p>
-        </p:txBody>
-      </p:sp>
-      <p:sp>
-        <p:nvSpPr>
-          <p:cNvPr id="14" name="Text 11"/>
-          <p:cNvSpPr/>
-          <p:nvPr/>
-        </p:nvSpPr>
-        <p:spPr>
-          <a:xfrm>
-            <a:off x="3749040" y="2414016"/>
-            <a:ext cx="2560320" cy="603504"/>
-          </a:xfrm>
-          <a:prstGeom prst="rect">
-            <a:avLst/>
-          </a:prstGeom>
-          <a:noFill/>
-          <a:ln/>
-        </p:spPr>
-        <p:txBody>
-          <a:bodyPr wrap="square" rtlCol="0" anchor="ctr"/>
-          <a:lstStyle/>
-          <a:p>
-            <a:pPr marL="0" indent="0">
-              <a:buNone/>
-            </a:pPr>
-            <a:r>
-              <a:rPr lang="en-US" sz="1300" b="1" dirty="0">
-                <a:solidFill>
-                  <a:srgbClr val="5B21B6"/>
-                </a:solidFill>
-                <a:latin typeface="Courier New" pitchFamily="34" charset="0"/>
-                <a:ea typeface="Courier New" pitchFamily="34" charset="-122"/>
-                <a:cs typeface="Courier New" pitchFamily="34" charset="-120"/>
-              </a:rPr>
-              <a:t>@path/to/file</a:t>
-            </a:r>
-            <a:endParaRPr lang="en-US" sz="1300" dirty="0"/>
-          </a:p>
-        </p:txBody>
-      </p:sp>
-      <p:sp>
-        <p:nvSpPr>
-          <p:cNvPr id="15" name="Text 12"/>
-          <p:cNvSpPr/>
-          <p:nvPr/>
-        </p:nvSpPr>
-        <p:spPr>
-          <a:xfrm>
-            <a:off x="6355080" y="2414016"/>
-            <a:ext cx="2286000" cy="603504"/>
-          </a:xfrm>
-          <a:prstGeom prst="rect">
-            <a:avLst/>
-          </a:prstGeom>
-          <a:noFill/>
-          <a:ln/>
-        </p:spPr>
-        <p:txBody>
-          <a:bodyPr wrap="square" rtlCol="0" anchor="ctr"/>
-          <a:lstStyle/>
-          <a:p>
-            <a:pPr marL="0" indent="0">
-              <a:buNone/>
-            </a:pPr>
-            <a:r>
-              <a:rPr lang="en-US" sz="1300" b="1" dirty="0">
-                <a:solidFill>
-                  <a:srgbClr val="7C3AED"/>
-                </a:solidFill>
-                <a:latin typeface="Courier New" pitchFamily="34" charset="0"/>
-                <a:ea typeface="Courier New" pitchFamily="34" charset="-122"/>
-                <a:cs typeface="Courier New" pitchFamily="34" charset="-120"/>
-              </a:rPr>
-              <a:t>@path/to/file</a:t>
-            </a:r>
-            <a:endParaRPr lang="en-US" sz="1300" dirty="0"/>
-          </a:p>
-        </p:txBody>
-      </p:sp>
-      <p:sp>
-        <p:nvSpPr>
-          <p:cNvPr id="16" name="Shape 13"/>
-          <p:cNvSpPr/>
-          <p:nvPr/>
-        </p:nvSpPr>
-        <p:spPr>
-          <a:xfrm>
-            <a:off x="457200" y="3017520"/>
-            <a:ext cx="8229600" cy="603504"/>
-          </a:xfrm>
-          <a:prstGeom prst="rect">
-            <a:avLst/>
-          </a:prstGeom>
-          <a:solidFill>
-            <a:srgbClr val="DDD6FE"/>
-          </a:solidFill>
-          <a:ln/>
-        </p:spPr>
-        <p:txBody>
-          <a:bodyPr/>
-          <a:lstStyle/>
-          <a:p>
-            <a:endParaRPr lang="en-AU"/>
-          </a:p>
-        </p:txBody>
-      </p:sp>
-      <p:sp>
-        <p:nvSpPr>
-          <p:cNvPr id="17" name="Text 14"/>
-          <p:cNvSpPr/>
-          <p:nvPr/>
-        </p:nvSpPr>
-        <p:spPr>
-          <a:xfrm>
-            <a:off x="640080" y="3017520"/>
-            <a:ext cx="3017520" cy="603504"/>
-          </a:xfrm>
-          <a:prstGeom prst="rect">
-            <a:avLst/>
-          </a:prstGeom>
-          <a:noFill/>
-          <a:ln/>
-        </p:spPr>
-        <p:txBody>
-          <a:bodyPr wrap="square" rtlCol="0" anchor="ctr"/>
-          <a:lstStyle/>
-          <a:p>
-            <a:pPr marL="0" indent="0">
-              <a:buNone/>
-            </a:pPr>
-            <a:r>
-              <a:rPr lang="en-US" sz="1250" dirty="0">
-                <a:solidFill>
-                  <a:srgbClr val="2D1155"/>
-                </a:solidFill>
-                <a:latin typeface="Calibri" pitchFamily="34" charset="0"/>
-                <a:ea typeface="Calibri" pitchFamily="34" charset="-122"/>
-                <a:cs typeface="Calibri" pitchFamily="34" charset="-120"/>
-              </a:rPr>
-              <a:t>Trim a bloated context</a:t>
-            </a:r>
-            <a:endParaRPr lang="en-US" sz="1250" dirty="0"/>
-          </a:p>
-        </p:txBody>
-      </p:sp>
-      <p:sp>
-        <p:nvSpPr>
-          <p:cNvPr id="18" name="Text 15"/>
-          <p:cNvSpPr/>
-          <p:nvPr/>
-        </p:nvSpPr>
-        <p:spPr>
-          <a:xfrm>
-            <a:off x="3749040" y="3017520"/>
-            <a:ext cx="2560320" cy="603504"/>
-          </a:xfrm>
-          <a:prstGeom prst="rect">
-            <a:avLst/>
-          </a:prstGeom>
-          <a:noFill/>
-          <a:ln/>
-        </p:spPr>
-        <p:txBody>
-          <a:bodyPr wrap="square" rtlCol="0" anchor="ctr"/>
-          <a:lstStyle/>
-          <a:p>
-            <a:pPr marL="0" indent="0">
-              <a:buNone/>
-            </a:pPr>
-            <a:r>
-              <a:rPr lang="en-US" sz="1300" b="1" dirty="0">
-                <a:solidFill>
-                  <a:srgbClr val="5B21B6"/>
-                </a:solidFill>
-                <a:latin typeface="Courier New" pitchFamily="34" charset="0"/>
-                <a:ea typeface="Courier New" pitchFamily="34" charset="-122"/>
-                <a:cs typeface="Courier New" pitchFamily="34" charset="-120"/>
-              </a:rPr>
-              <a:t>/compact</a:t>
-            </a:r>
-            <a:endParaRPr lang="en-US" sz="1300" dirty="0"/>
-          </a:p>
-        </p:txBody>
-      </p:sp>
-      <p:sp>
-        <p:nvSpPr>
-          <p:cNvPr id="19" name="Text 16"/>
-          <p:cNvSpPr/>
-          <p:nvPr/>
-        </p:nvSpPr>
-        <p:spPr>
-          <a:xfrm>
-            <a:off x="6355080" y="3017520"/>
-            <a:ext cx="2286000" cy="603504"/>
-          </a:xfrm>
-          <a:prstGeom prst="rect">
-            <a:avLst/>
-          </a:prstGeom>
-          <a:noFill/>
-          <a:ln/>
-        </p:spPr>
-        <p:txBody>
-          <a:bodyPr wrap="square" rtlCol="0" anchor="ctr"/>
-          <a:lstStyle/>
-          <a:p>
-            <a:pPr marL="0" indent="0">
-              <a:buNone/>
-            </a:pPr>
-            <a:r>
-              <a:rPr lang="en-US" sz="1300" b="1" dirty="0">
-                <a:solidFill>
-                  <a:srgbClr val="7C3AED"/>
-                </a:solidFill>
-                <a:latin typeface="Courier New" pitchFamily="34" charset="0"/>
-                <a:ea typeface="Courier New" pitchFamily="34" charset="-122"/>
-                <a:cs typeface="Courier New" pitchFamily="34" charset="-120"/>
-              </a:rPr>
-              <a:t>/compact</a:t>
-            </a:r>
-            <a:endParaRPr lang="en-US" sz="1300" dirty="0"/>
-          </a:p>
-        </p:txBody>
-      </p:sp>
-      <p:sp>
-        <p:nvSpPr>
-          <p:cNvPr id="20" name="Shape 17"/>
-          <p:cNvSpPr/>
-          <p:nvPr/>
-        </p:nvSpPr>
-        <p:spPr>
-          <a:xfrm>
-            <a:off x="457200" y="3621024"/>
-            <a:ext cx="8229600" cy="603504"/>
-          </a:xfrm>
-          <a:prstGeom prst="rect">
-            <a:avLst/>
-          </a:prstGeom>
-          <a:solidFill>
-            <a:srgbClr val="FFFFFF"/>
-          </a:solidFill>
-          <a:ln/>
-        </p:spPr>
-        <p:txBody>
-          <a:bodyPr/>
-          <a:lstStyle/>
-          <a:p>
-            <a:endParaRPr lang="en-AU"/>
-          </a:p>
-        </p:txBody>
-      </p:sp>
-      <p:sp>
-        <p:nvSpPr>
-          <p:cNvPr id="21" name="Text 18"/>
-          <p:cNvSpPr/>
-          <p:nvPr/>
-        </p:nvSpPr>
-        <p:spPr>
-          <a:xfrm>
-            <a:off x="640080" y="3621024"/>
-            <a:ext cx="3017520" cy="603504"/>
-          </a:xfrm>
-          <a:prstGeom prst="rect">
-            <a:avLst/>
-          </a:prstGeom>
-          <a:noFill/>
-          <a:ln/>
-        </p:spPr>
-        <p:txBody>
-          <a:bodyPr wrap="square" rtlCol="0" anchor="ctr"/>
-          <a:lstStyle/>
-          <a:p>
-            <a:pPr marL="0" indent="0">
-              <a:buNone/>
-            </a:pPr>
-            <a:r>
-              <a:rPr lang="en-US" sz="1250" dirty="0">
-                <a:solidFill>
-                  <a:srgbClr val="2D1155"/>
-                </a:solidFill>
-                <a:latin typeface="Calibri" pitchFamily="34" charset="0"/>
-                <a:ea typeface="Calibri" pitchFamily="34" charset="-122"/>
-                <a:cs typeface="Calibri" pitchFamily="34" charset="-120"/>
-              </a:rPr>
-              <a:t>Start fresh</a:t>
-            </a:r>
-            <a:endParaRPr lang="en-US" sz="1250" dirty="0"/>
-          </a:p>
-        </p:txBody>
-      </p:sp>
-      <p:sp>
-        <p:nvSpPr>
-          <p:cNvPr id="22" name="Text 19"/>
-          <p:cNvSpPr/>
-          <p:nvPr/>
-        </p:nvSpPr>
-        <p:spPr>
-          <a:xfrm>
-            <a:off x="3749040" y="3621024"/>
-            <a:ext cx="2560320" cy="603504"/>
-          </a:xfrm>
-          <a:prstGeom prst="rect">
-            <a:avLst/>
-          </a:prstGeom>
-          <a:noFill/>
-          <a:ln/>
-        </p:spPr>
-        <p:txBody>
-          <a:bodyPr wrap="square" rtlCol="0" anchor="ctr"/>
-          <a:lstStyle/>
-          <a:p>
-            <a:pPr marL="0" indent="0">
-              <a:buNone/>
-            </a:pPr>
-            <a:r>
-              <a:rPr lang="en-US" sz="1300" b="1" dirty="0">
-                <a:solidFill>
-                  <a:srgbClr val="5B21B6"/>
-                </a:solidFill>
-                <a:latin typeface="Courier New" pitchFamily="34" charset="0"/>
-                <a:ea typeface="Courier New" pitchFamily="34" charset="-122"/>
-                <a:cs typeface="Courier New" pitchFamily="34" charset="-120"/>
-              </a:rPr>
-              <a:t>/clear</a:t>
-            </a:r>
-            <a:endParaRPr lang="en-US" sz="1300" dirty="0"/>
-          </a:p>
-        </p:txBody>
-      </p:sp>
-      <p:sp>
-        <p:nvSpPr>
-          <p:cNvPr id="23" name="Text 20"/>
-          <p:cNvSpPr/>
-          <p:nvPr/>
-        </p:nvSpPr>
-        <p:spPr>
-          <a:xfrm>
-            <a:off x="6355080" y="3621024"/>
-            <a:ext cx="2286000" cy="603504"/>
-          </a:xfrm>
-          <a:prstGeom prst="rect">
-            <a:avLst/>
-          </a:prstGeom>
-          <a:noFill/>
-          <a:ln/>
-        </p:spPr>
-        <p:txBody>
-          <a:bodyPr wrap="square" rtlCol="0" anchor="ctr"/>
-          <a:lstStyle/>
-          <a:p>
-            <a:pPr marL="0" indent="0">
-              <a:buNone/>
-            </a:pPr>
-            <a:r>
-              <a:rPr lang="en-US" sz="1300" b="1" dirty="0">
-                <a:solidFill>
-                  <a:srgbClr val="7C3AED"/>
-                </a:solidFill>
-                <a:latin typeface="Courier New" pitchFamily="34" charset="0"/>
-                <a:ea typeface="Courier New" pitchFamily="34" charset="-122"/>
-                <a:cs typeface="Courier New" pitchFamily="34" charset="-120"/>
-              </a:rPr>
-              <a:t>new session</a:t>
-            </a:r>
-            <a:endParaRPr lang="en-US" sz="1300" dirty="0"/>
-          </a:p>
-        </p:txBody>
-      </p:sp>
-      <p:sp>
-        <p:nvSpPr>
-          <p:cNvPr id="24" name="Text 21"/>
-          <p:cNvSpPr/>
-          <p:nvPr/>
-        </p:nvSpPr>
-        <p:spPr>
-          <a:xfrm>
-            <a:off x="457200" y="4370832"/>
-            <a:ext cx="8229600" cy="320040"/>
-          </a:xfrm>
-          <a:prstGeom prst="rect">
-            <a:avLst/>
-          </a:prstGeom>
-          <a:noFill/>
-          <a:ln/>
-        </p:spPr>
-        <p:txBody>
-          <a:bodyPr wrap="square" rtlCol="0" anchor="ctr"/>
-          <a:lstStyle/>
-          <a:p>
-            <a:pPr marL="0" indent="0">
-              <a:buNone/>
-            </a:pPr>
-            <a:r>
-              <a:rPr lang="en-US" sz="1150" i="1" dirty="0">
-                <a:solidFill>
-                  <a:srgbClr val="6E6389"/>
-                </a:solidFill>
-                <a:latin typeface="Calibri" pitchFamily="34" charset="0"/>
-                <a:ea typeface="Calibri" pitchFamily="34" charset="-122"/>
-                <a:cs typeface="Calibri" pitchFamily="34" charset="-120"/>
-              </a:rPr>
-              <a:t>You don't need to memorise these — just know they exist and reach for them when answers go vague.</a:t>
-            </a:r>
-            <a:endParaRPr lang="en-US" sz="1150" dirty="0"/>
-          </a:p>
-        </p:txBody>
-      </p:sp>
-    </p:spTree>
-  </p:cSld>
-  <p:clrMapOvr>
-    <a:masterClrMapping/>
-  </p:clrMapOvr>
-</p:sld>
-</file>
-
-<file path=ppt/slides/slide11.xml><?xml version="1.0" encoding="utf-8"?>
-<p:sld xmlns:a="http://schemas.openxmlformats.org/drawingml/2006/main" xmlns:r="http://schemas.openxmlformats.org/officeDocument/2006/relationships" xmlns:p="http://schemas.openxmlformats.org/presentationml/2006/main">
   <p:cSld name="Slide 11">
     <p:bg>
       <p:bgPr>
@@ -3818,7 +2855,7 @@
 </p:sld>
 </file>
 
-<file path=ppt/slides/slide12.xml><?xml version="1.0" encoding="utf-8"?>
+<file path=ppt/slides/slide11.xml><?xml version="1.0" encoding="utf-8"?>
 <p:sld xmlns:a="http://schemas.openxmlformats.org/drawingml/2006/main" xmlns:r="http://schemas.openxmlformats.org/officeDocument/2006/relationships" xmlns:p="http://schemas.openxmlformats.org/presentationml/2006/main">
   <p:cSld name="Slide 12">
     <p:bg>
@@ -4401,7 +3438,7 @@
 </p:sld>
 </file>
 
-<file path=ppt/slides/slide13.xml><?xml version="1.0" encoding="utf-8"?>
+<file path=ppt/slides/slide12.xml><?xml version="1.0" encoding="utf-8"?>
 <p:sld xmlns:a="http://schemas.openxmlformats.org/drawingml/2006/main" xmlns:r="http://schemas.openxmlformats.org/officeDocument/2006/relationships" xmlns:p="http://schemas.openxmlformats.org/presentationml/2006/main">
   <p:cSld name="Slide 13">
     <p:bg>
@@ -4811,7 +3848,7 @@
 </p:sld>
 </file>
 
-<file path=ppt/slides/slide14.xml><?xml version="1.0" encoding="utf-8"?>
+<file path=ppt/slides/slide13.xml><?xml version="1.0" encoding="utf-8"?>
 <p:sld xmlns:a="http://schemas.openxmlformats.org/drawingml/2006/main" xmlns:r="http://schemas.openxmlformats.org/officeDocument/2006/relationships" xmlns:p="http://schemas.openxmlformats.org/presentationml/2006/main">
   <p:cSld name="Slide 14">
     <p:bg>
@@ -5644,7 +4681,7 @@
 </p:sld>
 </file>
 
-<file path=ppt/slides/slide15.xml><?xml version="1.0" encoding="utf-8"?>
+<file path=ppt/slides/slide14.xml><?xml version="1.0" encoding="utf-8"?>
 <p:sld xmlns:a="http://schemas.openxmlformats.org/drawingml/2006/main" xmlns:r="http://schemas.openxmlformats.org/officeDocument/2006/relationships" xmlns:p="http://schemas.openxmlformats.org/presentationml/2006/main">
   <p:cSld name="Slide 15">
     <p:bg>
@@ -6217,7 +5254,7 @@
 </p:sld>
 </file>
 
-<file path=ppt/slides/slide16.xml><?xml version="1.0" encoding="utf-8"?>
+<file path=ppt/slides/slide15.xml><?xml version="1.0" encoding="utf-8"?>
 <p:sld xmlns:a="http://schemas.openxmlformats.org/drawingml/2006/main" xmlns:r="http://schemas.openxmlformats.org/officeDocument/2006/relationships" xmlns:p="http://schemas.openxmlformats.org/presentationml/2006/main">
   <p:cSld name="Slide 16">
     <p:bg>
@@ -6932,7 +5969,7 @@
 </p:sld>
 </file>
 
-<file path=ppt/slides/slide17.xml><?xml version="1.0" encoding="utf-8"?>
+<file path=ppt/slides/slide16.xml><?xml version="1.0" encoding="utf-8"?>
 <p:sld xmlns:a="http://schemas.openxmlformats.org/drawingml/2006/main" xmlns:r="http://schemas.openxmlformats.org/officeDocument/2006/relationships" xmlns:p="http://schemas.openxmlformats.org/presentationml/2006/main">
   <p:cSld name="Slide 17">
     <p:bg>
@@ -7252,657 +6289,6 @@
 
 <file path=ppt/slides/slide2.xml><?xml version="1.0" encoding="utf-8"?>
 <p:sld xmlns:a="http://schemas.openxmlformats.org/drawingml/2006/main" xmlns:r="http://schemas.openxmlformats.org/officeDocument/2006/relationships" xmlns:p="http://schemas.openxmlformats.org/presentationml/2006/main">
-  <p:cSld name="Slide 2">
-    <p:bg>
-      <p:bgPr>
-        <a:solidFill>
-          <a:srgbClr val="F5F3FF"/>
-        </a:solidFill>
-        <a:effectLst/>
-      </p:bgPr>
-    </p:bg>
-    <p:spTree>
-      <p:nvGrpSpPr>
-        <p:cNvPr id="1" name=""/>
-        <p:cNvGrpSpPr/>
-        <p:nvPr/>
-      </p:nvGrpSpPr>
-      <p:grpSpPr>
-        <a:xfrm>
-          <a:off x="0" y="0"/>
-          <a:ext cx="0" cy="0"/>
-          <a:chOff x="0" y="0"/>
-          <a:chExt cx="0" cy="0"/>
-        </a:xfrm>
-      </p:grpSpPr>
-      <p:sp>
-        <p:nvSpPr>
-          <p:cNvPr id="2" name="Text 0"/>
-          <p:cNvSpPr/>
-          <p:nvPr/>
-        </p:nvSpPr>
-        <p:spPr>
-          <a:xfrm>
-            <a:off x="457200" y="292608"/>
-            <a:ext cx="8229600" cy="566928"/>
-          </a:xfrm>
-          <a:prstGeom prst="rect">
-            <a:avLst/>
-          </a:prstGeom>
-          <a:noFill/>
-          <a:ln/>
-        </p:spPr>
-        <p:txBody>
-          <a:bodyPr wrap="square" rtlCol="0" anchor="ctr"/>
-          <a:lstStyle/>
-          <a:p>
-            <a:pPr marL="0" indent="0" algn="l">
-              <a:buNone/>
-            </a:pPr>
-            <a:r>
-              <a:rPr lang="en-US" sz="2200" b="1" kern="0" spc="100" dirty="0">
-                <a:solidFill>
-                  <a:srgbClr val="2D1155"/>
-                </a:solidFill>
-                <a:latin typeface="Arial Black" pitchFamily="34" charset="0"/>
-                <a:ea typeface="Arial Black" pitchFamily="34" charset="-122"/>
-                <a:cs typeface="Arial Black" pitchFamily="34" charset="-120"/>
-              </a:rPr>
-              <a:t>TWO KINDS OF ENGINEER</a:t>
-            </a:r>
-            <a:endParaRPr lang="en-US" sz="2200" dirty="0"/>
-          </a:p>
-        </p:txBody>
-      </p:sp>
-      <p:sp>
-        <p:nvSpPr>
-          <p:cNvPr id="3" name="Text 1"/>
-          <p:cNvSpPr/>
-          <p:nvPr/>
-        </p:nvSpPr>
-        <p:spPr>
-          <a:xfrm>
-            <a:off x="475488" y="896112"/>
-            <a:ext cx="8229600" cy="329184"/>
-          </a:xfrm>
-          <a:prstGeom prst="rect">
-            <a:avLst/>
-          </a:prstGeom>
-          <a:noFill/>
-          <a:ln/>
-        </p:spPr>
-        <p:txBody>
-          <a:bodyPr wrap="square" rtlCol="0" anchor="ctr"/>
-          <a:lstStyle/>
-          <a:p>
-            <a:pPr marL="0" indent="0">
-              <a:buNone/>
-            </a:pPr>
-            <a:r>
-              <a:rPr lang="en-US" sz="1300" i="1" dirty="0">
-                <a:solidFill>
-                  <a:srgbClr val="6E6389"/>
-                </a:solidFill>
-                <a:latin typeface="Calibri" pitchFamily="34" charset="0"/>
-                <a:ea typeface="Calibri" pitchFamily="34" charset="-122"/>
-                <a:cs typeface="Calibri" pitchFamily="34" charset="-120"/>
-              </a:rPr>
-              <a:t>Both leave with something new.</a:t>
-            </a:r>
-            <a:endParaRPr lang="en-US" sz="1300" dirty="0"/>
-          </a:p>
-        </p:txBody>
-      </p:sp>
-      <p:pic>
-        <p:nvPicPr>
-          <p:cNvPr id="4" name="Image 0" descr="logo_icon.jpeg"/>
-          <p:cNvPicPr>
-            <a:picLocks noChangeAspect="1"/>
-          </p:cNvPicPr>
-          <p:nvPr/>
-        </p:nvPicPr>
-        <p:blipFill>
-          <a:blip r:embed="rId3"/>
-          <a:stretch>
-            <a:fillRect/>
-          </a:stretch>
-        </p:blipFill>
-        <p:spPr>
-          <a:xfrm>
-            <a:off x="8366760" y="4526280"/>
-            <a:ext cx="411480" cy="411480"/>
-          </a:xfrm>
-          <a:prstGeom prst="ellipse">
-            <a:avLst/>
-          </a:prstGeom>
-        </p:spPr>
-      </p:pic>
-      <p:sp>
-        <p:nvSpPr>
-          <p:cNvPr id="5" name="Shape 2"/>
-          <p:cNvSpPr/>
-          <p:nvPr/>
-        </p:nvSpPr>
-        <p:spPr>
-          <a:xfrm>
-            <a:off x="457200" y="1417320"/>
-            <a:ext cx="3931920" cy="3246120"/>
-          </a:xfrm>
-          <a:prstGeom prst="roundRect">
-            <a:avLst>
-              <a:gd name="adj" fmla="val 2535"/>
-            </a:avLst>
-          </a:prstGeom>
-          <a:solidFill>
-            <a:srgbClr val="2D1155"/>
-          </a:solidFill>
-          <a:ln/>
-        </p:spPr>
-        <p:txBody>
-          <a:bodyPr/>
-          <a:lstStyle/>
-          <a:p>
-            <a:endParaRPr lang="en-AU"/>
-          </a:p>
-        </p:txBody>
-      </p:sp>
-      <p:sp>
-        <p:nvSpPr>
-          <p:cNvPr id="6" name="Shape 3"/>
-          <p:cNvSpPr/>
-          <p:nvPr/>
-        </p:nvSpPr>
-        <p:spPr>
-          <a:xfrm>
-            <a:off x="713232" y="1673352"/>
-            <a:ext cx="566928" cy="566928"/>
-          </a:xfrm>
-          <a:prstGeom prst="ellipse">
-            <a:avLst/>
-          </a:prstGeom>
-          <a:solidFill>
-            <a:srgbClr val="F59E0B"/>
-          </a:solidFill>
-          <a:ln/>
-        </p:spPr>
-        <p:txBody>
-          <a:bodyPr/>
-          <a:lstStyle/>
-          <a:p>
-            <a:endParaRPr lang="en-AU"/>
-          </a:p>
-        </p:txBody>
-      </p:sp>
-      <p:sp>
-        <p:nvSpPr>
-          <p:cNvPr id="7" name="Text 4"/>
-          <p:cNvSpPr/>
-          <p:nvPr/>
-        </p:nvSpPr>
-        <p:spPr>
-          <a:xfrm>
-            <a:off x="713232" y="1673352"/>
-            <a:ext cx="566928" cy="566928"/>
-          </a:xfrm>
-          <a:prstGeom prst="rect">
-            <a:avLst/>
-          </a:prstGeom>
-          <a:noFill/>
-          <a:ln/>
-        </p:spPr>
-        <p:txBody>
-          <a:bodyPr wrap="square" rtlCol="0" anchor="ctr"/>
-          <a:lstStyle/>
-          <a:p>
-            <a:pPr marL="0" indent="0" algn="ctr">
-              <a:buNone/>
-            </a:pPr>
-            <a:r>
-              <a:rPr lang="en-US" sz="1200" b="1" dirty="0">
-                <a:solidFill>
-                  <a:srgbClr val="FFFFFF"/>
-                </a:solidFill>
-                <a:latin typeface="Arial Black" pitchFamily="34" charset="0"/>
-                <a:ea typeface="Arial Black" pitchFamily="34" charset="-122"/>
-                <a:cs typeface="Arial Black" pitchFamily="34" charset="-120"/>
-              </a:rPr>
-              <a:t>R</a:t>
-            </a:r>
-            <a:endParaRPr lang="en-US" sz="1200" dirty="0"/>
-          </a:p>
-        </p:txBody>
-      </p:sp>
-      <p:sp>
-        <p:nvSpPr>
-          <p:cNvPr id="8" name="Text 5"/>
-          <p:cNvSpPr/>
-          <p:nvPr/>
-        </p:nvSpPr>
-        <p:spPr>
-          <a:xfrm>
-            <a:off x="1417320" y="1700784"/>
-            <a:ext cx="2834640" cy="502920"/>
-          </a:xfrm>
-          <a:prstGeom prst="rect">
-            <a:avLst/>
-          </a:prstGeom>
-          <a:noFill/>
-          <a:ln/>
-        </p:spPr>
-        <p:txBody>
-          <a:bodyPr wrap="square" rtlCol="0" anchor="ctr"/>
-          <a:lstStyle/>
-          <a:p>
-            <a:pPr marL="0" indent="0">
-              <a:buNone/>
-            </a:pPr>
-            <a:r>
-              <a:rPr lang="en-US" sz="1600" b="1" dirty="0">
-                <a:solidFill>
-                  <a:srgbClr val="F59E0B"/>
-                </a:solidFill>
-                <a:latin typeface="Arial Black" pitchFamily="34" charset="0"/>
-                <a:ea typeface="Arial Black" pitchFamily="34" charset="-122"/>
-                <a:cs typeface="Arial Black" pitchFamily="34" charset="-120"/>
-              </a:rPr>
-              <a:t>The rusty one</a:t>
-            </a:r>
-            <a:endParaRPr lang="en-US" sz="1600" dirty="0"/>
-          </a:p>
-        </p:txBody>
-      </p:sp>
-      <p:sp>
-        <p:nvSpPr>
-          <p:cNvPr id="9" name="Text 6"/>
-          <p:cNvSpPr/>
-          <p:nvPr/>
-        </p:nvSpPr>
-        <p:spPr>
-          <a:xfrm>
-            <a:off x="731520" y="2331720"/>
-            <a:ext cx="3429000" cy="457200"/>
-          </a:xfrm>
-          <a:prstGeom prst="rect">
-            <a:avLst/>
-          </a:prstGeom>
-          <a:noFill/>
-          <a:ln/>
-        </p:spPr>
-        <p:txBody>
-          <a:bodyPr wrap="square" rtlCol="0" anchor="t"/>
-          <a:lstStyle/>
-          <a:p>
-            <a:pPr marL="0" indent="0">
-              <a:buNone/>
-            </a:pPr>
-            <a:r>
-              <a:rPr lang="en-US" sz="1200" i="1" dirty="0">
-                <a:solidFill>
-                  <a:srgbClr val="DDD6FE"/>
-                </a:solidFill>
-                <a:latin typeface="Calibri" pitchFamily="34" charset="0"/>
-                <a:ea typeface="Calibri" pitchFamily="34" charset="-122"/>
-                <a:cs typeface="Calibri" pitchFamily="34" charset="-120"/>
-              </a:rPr>
-              <a:t>Back from leave. Tooling moved. Feeling behind.</a:t>
-            </a:r>
-            <a:endParaRPr lang="en-US" sz="1200" dirty="0"/>
-          </a:p>
-        </p:txBody>
-      </p:sp>
-      <p:sp>
-        <p:nvSpPr>
-          <p:cNvPr id="10" name="Text 7"/>
-          <p:cNvSpPr/>
-          <p:nvPr/>
-        </p:nvSpPr>
-        <p:spPr>
-          <a:xfrm>
-            <a:off x="731520" y="2852928"/>
-            <a:ext cx="3474720" cy="1691640"/>
-          </a:xfrm>
-          <a:prstGeom prst="rect">
-            <a:avLst/>
-          </a:prstGeom>
-          <a:noFill/>
-          <a:ln/>
-        </p:spPr>
-        <p:txBody>
-          <a:bodyPr wrap="square" rtlCol="0" anchor="t"/>
-          <a:lstStyle/>
-          <a:p>
-            <a:pPr marL="152400" indent="-152400">
-              <a:spcAft>
-                <a:spcPts val="700"/>
-              </a:spcAft>
-              <a:buSzPct val="100000"/>
-              <a:buChar char="•"/>
-            </a:pPr>
-            <a:r>
-              <a:rPr lang="en-US" sz="1200" dirty="0">
-                <a:solidFill>
-                  <a:srgbClr val="FFFFFF"/>
-                </a:solidFill>
-                <a:latin typeface="Calibri" pitchFamily="34" charset="0"/>
-                <a:ea typeface="Calibri" pitchFamily="34" charset="-122"/>
-                <a:cs typeface="Calibri" pitchFamily="34" charset="-120"/>
-              </a:rPr>
-              <a:t>Learns the loop and the tools.</a:t>
-            </a:r>
-            <a:endParaRPr lang="en-US" sz="1200" dirty="0"/>
-          </a:p>
-          <a:p>
-            <a:pPr marL="152400" indent="-152400">
-              <a:spcAft>
-                <a:spcPts val="700"/>
-              </a:spcAft>
-              <a:buSzPct val="100000"/>
-              <a:buChar char="•"/>
-            </a:pPr>
-            <a:r>
-              <a:rPr lang="en-US" sz="1200" dirty="0">
-                <a:solidFill>
-                  <a:srgbClr val="FFFFFF"/>
-                </a:solidFill>
-                <a:latin typeface="Calibri" pitchFamily="34" charset="0"/>
-                <a:ea typeface="Calibri" pitchFamily="34" charset="-122"/>
-                <a:cs typeface="Calibri" pitchFamily="34" charset="-120"/>
-              </a:rPr>
-              <a:t>The mechanical part - typing tokens - is exactly what got automated while you were away.</a:t>
-            </a:r>
-            <a:endParaRPr lang="en-US" sz="1200" dirty="0"/>
-          </a:p>
-          <a:p>
-            <a:pPr marL="152400" indent="-152400">
-              <a:spcAft>
-                <a:spcPts val="700"/>
-              </a:spcAft>
-              <a:buSzPct val="100000"/>
-              <a:buChar char="•"/>
-            </a:pPr>
-            <a:r>
-              <a:rPr lang="en-US" sz="1200" b="1" dirty="0">
-                <a:solidFill>
-                  <a:srgbClr val="F59E0B"/>
-                </a:solidFill>
-                <a:latin typeface="Calibri" pitchFamily="34" charset="0"/>
-                <a:ea typeface="Calibri" pitchFamily="34" charset="-122"/>
-                <a:cs typeface="Calibri" pitchFamily="34" charset="-120"/>
-              </a:rPr>
-              <a:t>Your judgement did not expire.</a:t>
-            </a:r>
-            <a:endParaRPr lang="en-US" sz="1200" dirty="0"/>
-          </a:p>
-        </p:txBody>
-      </p:sp>
-      <p:sp>
-        <p:nvSpPr>
-          <p:cNvPr id="11" name="Shape 8"/>
-          <p:cNvSpPr/>
-          <p:nvPr/>
-        </p:nvSpPr>
-        <p:spPr>
-          <a:xfrm>
-            <a:off x="4754880" y="1417320"/>
-            <a:ext cx="3931920" cy="3246120"/>
-          </a:xfrm>
-          <a:prstGeom prst="roundRect">
-            <a:avLst>
-              <a:gd name="adj" fmla="val 2535"/>
-            </a:avLst>
-          </a:prstGeom>
-          <a:solidFill>
-            <a:srgbClr val="2D1155"/>
-          </a:solidFill>
-          <a:ln/>
-        </p:spPr>
-        <p:txBody>
-          <a:bodyPr/>
-          <a:lstStyle/>
-          <a:p>
-            <a:endParaRPr lang="en-AU"/>
-          </a:p>
-        </p:txBody>
-      </p:sp>
-      <p:sp>
-        <p:nvSpPr>
-          <p:cNvPr id="12" name="Shape 9"/>
-          <p:cNvSpPr/>
-          <p:nvPr/>
-        </p:nvSpPr>
-        <p:spPr>
-          <a:xfrm>
-            <a:off x="5010912" y="1673352"/>
-            <a:ext cx="566928" cy="566928"/>
-          </a:xfrm>
-          <a:prstGeom prst="ellipse">
-            <a:avLst/>
-          </a:prstGeom>
-          <a:solidFill>
-            <a:srgbClr val="7C3AED"/>
-          </a:solidFill>
-          <a:ln/>
-        </p:spPr>
-        <p:txBody>
-          <a:bodyPr/>
-          <a:lstStyle/>
-          <a:p>
-            <a:endParaRPr lang="en-AU"/>
-          </a:p>
-        </p:txBody>
-      </p:sp>
-      <p:sp>
-        <p:nvSpPr>
-          <p:cNvPr id="13" name="Text 10"/>
-          <p:cNvSpPr/>
-          <p:nvPr/>
-        </p:nvSpPr>
-        <p:spPr>
-          <a:xfrm>
-            <a:off x="5010912" y="1673352"/>
-            <a:ext cx="566928" cy="566928"/>
-          </a:xfrm>
-          <a:prstGeom prst="rect">
-            <a:avLst/>
-          </a:prstGeom>
-          <a:noFill/>
-          <a:ln/>
-        </p:spPr>
-        <p:txBody>
-          <a:bodyPr wrap="square" rtlCol="0" anchor="ctr"/>
-          <a:lstStyle/>
-          <a:p>
-            <a:pPr marL="0" indent="0" algn="ctr">
-              <a:buNone/>
-            </a:pPr>
-            <a:r>
-              <a:rPr lang="en-US" sz="1200" b="1" dirty="0">
-                <a:solidFill>
-                  <a:srgbClr val="FFFFFF"/>
-                </a:solidFill>
-                <a:latin typeface="Arial Black" pitchFamily="34" charset="0"/>
-                <a:ea typeface="Arial Black" pitchFamily="34" charset="-122"/>
-                <a:cs typeface="Arial Black" pitchFamily="34" charset="-120"/>
-              </a:rPr>
-              <a:t>C</a:t>
-            </a:r>
-            <a:endParaRPr lang="en-US" sz="1200" dirty="0"/>
-          </a:p>
-        </p:txBody>
-      </p:sp>
-      <p:sp>
-        <p:nvSpPr>
-          <p:cNvPr id="14" name="Text 11"/>
-          <p:cNvSpPr/>
-          <p:nvPr/>
-        </p:nvSpPr>
-        <p:spPr>
-          <a:xfrm>
-            <a:off x="5715000" y="1700784"/>
-            <a:ext cx="2834640" cy="502920"/>
-          </a:xfrm>
-          <a:prstGeom prst="rect">
-            <a:avLst/>
-          </a:prstGeom>
-          <a:noFill/>
-          <a:ln/>
-        </p:spPr>
-        <p:txBody>
-          <a:bodyPr wrap="square" rtlCol="0" anchor="ctr"/>
-          <a:lstStyle/>
-          <a:p>
-            <a:pPr marL="0" indent="0">
-              <a:buNone/>
-            </a:pPr>
-            <a:r>
-              <a:rPr lang="en-US" sz="1600" b="1" dirty="0">
-                <a:solidFill>
-                  <a:srgbClr val="7C3AED"/>
-                </a:solidFill>
-                <a:latin typeface="Arial Black" pitchFamily="34" charset="0"/>
-                <a:ea typeface="Arial Black" pitchFamily="34" charset="-122"/>
-                <a:cs typeface="Arial Black" pitchFamily="34" charset="-120"/>
-              </a:rPr>
-              <a:t>The confident one</a:t>
-            </a:r>
-            <a:endParaRPr lang="en-US" sz="1600" dirty="0"/>
-          </a:p>
-        </p:txBody>
-      </p:sp>
-      <p:sp>
-        <p:nvSpPr>
-          <p:cNvPr id="15" name="Text 12"/>
-          <p:cNvSpPr/>
-          <p:nvPr/>
-        </p:nvSpPr>
-        <p:spPr>
-          <a:xfrm>
-            <a:off x="5029200" y="2331720"/>
-            <a:ext cx="3429000" cy="457200"/>
-          </a:xfrm>
-          <a:prstGeom prst="rect">
-            <a:avLst/>
-          </a:prstGeom>
-          <a:noFill/>
-          <a:ln/>
-        </p:spPr>
-        <p:txBody>
-          <a:bodyPr wrap="square" rtlCol="0" anchor="t"/>
-          <a:lstStyle/>
-          <a:p>
-            <a:pPr marL="0" indent="0">
-              <a:buNone/>
-            </a:pPr>
-            <a:r>
-              <a:rPr lang="en-US" sz="1200" i="1" dirty="0">
-                <a:solidFill>
-                  <a:srgbClr val="DDD6FE"/>
-                </a:solidFill>
-                <a:latin typeface="Calibri" pitchFamily="34" charset="0"/>
-                <a:ea typeface="Calibri" pitchFamily="34" charset="-122"/>
-                <a:cs typeface="Calibri" pitchFamily="34" charset="-120"/>
-              </a:rPr>
-              <a:t>Ships fast by hand. Trusts their own fingers.</a:t>
-            </a:r>
-            <a:endParaRPr lang="en-US" sz="1200" dirty="0"/>
-          </a:p>
-        </p:txBody>
-      </p:sp>
-      <p:sp>
-        <p:nvSpPr>
-          <p:cNvPr id="16" name="Text 13"/>
-          <p:cNvSpPr/>
-          <p:nvPr/>
-        </p:nvSpPr>
-        <p:spPr>
-          <a:xfrm>
-            <a:off x="5029200" y="2852928"/>
-            <a:ext cx="3474720" cy="1691640"/>
-          </a:xfrm>
-          <a:prstGeom prst="rect">
-            <a:avLst/>
-          </a:prstGeom>
-          <a:noFill/>
-          <a:ln/>
-        </p:spPr>
-        <p:txBody>
-          <a:bodyPr wrap="square" rtlCol="0" anchor="t"/>
-          <a:lstStyle/>
-          <a:p>
-            <a:pPr marL="152400" indent="-152400">
-              <a:spcAft>
-                <a:spcPts val="700"/>
-              </a:spcAft>
-              <a:buSzPct val="100000"/>
-              <a:buChar char="•"/>
-            </a:pPr>
-            <a:r>
-              <a:rPr lang="en-US" sz="1200" dirty="0">
-                <a:solidFill>
-                  <a:srgbClr val="FFFFFF"/>
-                </a:solidFill>
-                <a:latin typeface="Calibri" pitchFamily="34" charset="0"/>
-                <a:ea typeface="Calibri" pitchFamily="34" charset="-122"/>
-                <a:cs typeface="Calibri" pitchFamily="34" charset="-120"/>
-              </a:rPr>
-              <a:t>Learns to give up the keyboard.</a:t>
-            </a:r>
-            <a:endParaRPr lang="en-US" sz="1200" dirty="0"/>
-          </a:p>
-          <a:p>
-            <a:pPr marL="152400" indent="-152400">
-              <a:spcAft>
-                <a:spcPts val="700"/>
-              </a:spcAft>
-              <a:buSzPct val="100000"/>
-              <a:buChar char="•"/>
-            </a:pPr>
-            <a:r>
-              <a:rPr lang="en-US" sz="1200" dirty="0">
-                <a:solidFill>
-                  <a:srgbClr val="FFFFFF"/>
-                </a:solidFill>
-                <a:latin typeface="Calibri" pitchFamily="34" charset="0"/>
-                <a:ea typeface="Calibri" pitchFamily="34" charset="-122"/>
-                <a:cs typeface="Calibri" pitchFamily="34" charset="-120"/>
-              </a:rPr>
-              <a:t>Harder for you - more habits to unlearn.</a:t>
-            </a:r>
-            <a:endParaRPr lang="en-US" sz="1200" dirty="0"/>
-          </a:p>
-          <a:p>
-            <a:pPr marL="152400" indent="-152400">
-              <a:spcAft>
-                <a:spcPts val="700"/>
-              </a:spcAft>
-              <a:buSzPct val="100000"/>
-              <a:buChar char="•"/>
-            </a:pPr>
-            <a:r>
-              <a:rPr lang="en-US" sz="1200" b="1" dirty="0">
-                <a:solidFill>
-                  <a:srgbClr val="DDD6FE"/>
-                </a:solidFill>
-                <a:latin typeface="Calibri" pitchFamily="34" charset="0"/>
-                <a:ea typeface="Calibri" pitchFamily="34" charset="-122"/>
-                <a:cs typeface="Calibri" pitchFamily="34" charset="-120"/>
-              </a:rPr>
-              <a:t>Direct the work instead of doing it.</a:t>
-            </a:r>
-            <a:endParaRPr lang="en-US" sz="1200" dirty="0"/>
-          </a:p>
-        </p:txBody>
-      </p:sp>
-    </p:spTree>
-  </p:cSld>
-  <p:clrMapOvr>
-    <a:masterClrMapping/>
-  </p:clrMapOvr>
-</p:sld>
-</file>
-
-<file path=ppt/slides/slide3.xml><?xml version="1.0" encoding="utf-8"?>
-<p:sld xmlns:a="http://schemas.openxmlformats.org/drawingml/2006/main" xmlns:r="http://schemas.openxmlformats.org/officeDocument/2006/relationships" xmlns:p="http://schemas.openxmlformats.org/presentationml/2006/main">
   <p:cSld name="Slide 3">
     <p:bg>
       <p:bgPr>
@@ -8557,7 +6943,7 @@
 </p:sld>
 </file>
 
-<file path=ppt/slides/slide4.xml><?xml version="1.0" encoding="utf-8"?>
+<file path=ppt/slides/slide3.xml><?xml version="1.0" encoding="utf-8"?>
 <p:sld xmlns:a="http://schemas.openxmlformats.org/drawingml/2006/main" xmlns:r="http://schemas.openxmlformats.org/officeDocument/2006/relationships" xmlns:p="http://schemas.openxmlformats.org/presentationml/2006/main">
   <p:cSld name="Slide 4">
     <p:bg>
@@ -8949,7 +7335,7 @@
 </p:sld>
 </file>
 
-<file path=ppt/slides/slide5.xml><?xml version="1.0" encoding="utf-8"?>
+<file path=ppt/slides/slide4.xml><?xml version="1.0" encoding="utf-8"?>
 <p:sld xmlns:a="http://schemas.openxmlformats.org/drawingml/2006/main" xmlns:r="http://schemas.openxmlformats.org/officeDocument/2006/relationships" xmlns:p="http://schemas.openxmlformats.org/presentationml/2006/main">
   <p:cSld name="Slide 5">
     <p:bg>
@@ -10049,7 +8435,7 @@
 </p:sld>
 </file>
 
-<file path=ppt/slides/slide6.xml><?xml version="1.0" encoding="utf-8"?>
+<file path=ppt/slides/slide5.xml><?xml version="1.0" encoding="utf-8"?>
 <p:sld xmlns:a="http://schemas.openxmlformats.org/drawingml/2006/main" xmlns:r="http://schemas.openxmlformats.org/officeDocument/2006/relationships" xmlns:p="http://schemas.openxmlformats.org/presentationml/2006/main">
   <p:cSld name="Slide 6">
     <p:bg>
@@ -10926,7 +9312,7 @@
 </p:sld>
 </file>
 
-<file path=ppt/slides/slide7.xml><?xml version="1.0" encoding="utf-8"?>
+<file path=ppt/slides/slide6.xml><?xml version="1.0" encoding="utf-8"?>
 <p:sld xmlns:a="http://schemas.openxmlformats.org/drawingml/2006/main" xmlns:r="http://schemas.openxmlformats.org/officeDocument/2006/relationships" xmlns:p="http://schemas.openxmlformats.org/presentationml/2006/main">
   <p:cSld name="Slide 7">
     <p:bg>
@@ -11320,7 +9706,7 @@
 </p:sld>
 </file>
 
-<file path=ppt/slides/slide8.xml><?xml version="1.0" encoding="utf-8"?>
+<file path=ppt/slides/slide7.xml><?xml version="1.0" encoding="utf-8"?>
 <p:sld xmlns:a="http://schemas.openxmlformats.org/drawingml/2006/main" xmlns:r="http://schemas.openxmlformats.org/officeDocument/2006/relationships" xmlns:p="http://schemas.openxmlformats.org/presentationml/2006/main">
   <p:cSld name="Slide 8">
     <p:bg>
@@ -11947,7 +10333,7 @@
 </p:sld>
 </file>
 
-<file path=ppt/slides/slide9.xml><?xml version="1.0" encoding="utf-8"?>
+<file path=ppt/slides/slide8.xml><?xml version="1.0" encoding="utf-8"?>
 <p:sld xmlns:a="http://schemas.openxmlformats.org/drawingml/2006/main" xmlns:r="http://schemas.openxmlformats.org/officeDocument/2006/relationships" xmlns:p="http://schemas.openxmlformats.org/presentationml/2006/main">
   <p:cSld name="Slide 9">
     <p:bg>
@@ -12520,6 +10906,873 @@
               <a:t>Codex: /plan</a:t>
             </a:r>
             <a:endParaRPr lang="en-US" sz="1200" dirty="0"/>
+          </a:p>
+        </p:txBody>
+      </p:sp>
+    </p:spTree>
+  </p:cSld>
+  <p:clrMapOvr>
+    <a:masterClrMapping/>
+  </p:clrMapOvr>
+</p:sld>
+</file>
+
+<file path=ppt/slides/slide9.xml><?xml version="1.0" encoding="utf-8"?>
+<p:sld xmlns:a="http://schemas.openxmlformats.org/drawingml/2006/main" xmlns:r="http://schemas.openxmlformats.org/officeDocument/2006/relationships" xmlns:p="http://schemas.openxmlformats.org/presentationml/2006/main">
+  <p:cSld name="Slide 10">
+    <p:bg>
+      <p:bgPr>
+        <a:solidFill>
+          <a:srgbClr val="F5F3FF"/>
+        </a:solidFill>
+        <a:effectLst/>
+      </p:bgPr>
+    </p:bg>
+    <p:spTree>
+      <p:nvGrpSpPr>
+        <p:cNvPr id="1" name=""/>
+        <p:cNvGrpSpPr/>
+        <p:nvPr/>
+      </p:nvGrpSpPr>
+      <p:grpSpPr>
+        <a:xfrm>
+          <a:off x="0" y="0"/>
+          <a:ext cx="0" cy="0"/>
+          <a:chOff x="0" y="0"/>
+          <a:chExt cx="0" cy="0"/>
+        </a:xfrm>
+      </p:grpSpPr>
+      <p:sp>
+        <p:nvSpPr>
+          <p:cNvPr id="2" name="Text 0"/>
+          <p:cNvSpPr/>
+          <p:nvPr/>
+        </p:nvSpPr>
+        <p:spPr>
+          <a:xfrm>
+            <a:off x="457200" y="292608"/>
+            <a:ext cx="8229600" cy="566928"/>
+          </a:xfrm>
+          <a:prstGeom prst="rect">
+            <a:avLst/>
+          </a:prstGeom>
+          <a:noFill/>
+          <a:ln/>
+        </p:spPr>
+        <p:txBody>
+          <a:bodyPr wrap="square" rtlCol="0" anchor="ctr"/>
+          <a:lstStyle/>
+          <a:p>
+            <a:pPr marL="0" indent="0" algn="l">
+              <a:buNone/>
+            </a:pPr>
+            <a:r>
+              <a:rPr lang="en-US" sz="2700" b="1" kern="0" spc="100" dirty="0">
+                <a:solidFill>
+                  <a:srgbClr val="2D1155"/>
+                </a:solidFill>
+                <a:latin typeface="Arial Black" pitchFamily="34" charset="0"/>
+                <a:ea typeface="Arial Black" pitchFamily="34" charset="-122"/>
+                <a:cs typeface="Arial Black" pitchFamily="34" charset="-120"/>
+              </a:rPr>
+              <a:t>THE COCKPIT</a:t>
+            </a:r>
+            <a:endParaRPr lang="en-US" sz="2700" dirty="0"/>
+          </a:p>
+        </p:txBody>
+      </p:sp>
+      <p:sp>
+        <p:nvSpPr>
+          <p:cNvPr id="3" name="Text 1"/>
+          <p:cNvSpPr/>
+          <p:nvPr/>
+        </p:nvSpPr>
+        <p:spPr>
+          <a:xfrm>
+            <a:off x="475488" y="896112"/>
+            <a:ext cx="8229600" cy="329184"/>
+          </a:xfrm>
+          <a:prstGeom prst="rect">
+            <a:avLst/>
+          </a:prstGeom>
+          <a:noFill/>
+          <a:ln/>
+        </p:spPr>
+        <p:txBody>
+          <a:bodyPr wrap="square" rtlCol="0" anchor="ctr"/>
+          <a:lstStyle/>
+          <a:p>
+            <a:pPr marL="0" indent="0">
+              <a:buNone/>
+            </a:pPr>
+            <a:r>
+              <a:rPr lang="en-US" sz="1300" i="1" dirty="0">
+                <a:solidFill>
+                  <a:srgbClr val="6E6389"/>
+                </a:solidFill>
+                <a:latin typeface="Calibri" pitchFamily="34" charset="0"/>
+                <a:ea typeface="Calibri" pitchFamily="34" charset="-122"/>
+                <a:cs typeface="Calibri" pitchFamily="34" charset="-120"/>
+              </a:rPr>
+              <a:t>Skill #3 — the handful of commands that put you in control.</a:t>
+            </a:r>
+            <a:endParaRPr lang="en-US" sz="1300" dirty="0"/>
+          </a:p>
+        </p:txBody>
+      </p:sp>
+      <p:pic>
+        <p:nvPicPr>
+          <p:cNvPr id="4" name="Image 0" descr="logo_icon.jpeg"/>
+          <p:cNvPicPr>
+            <a:picLocks noChangeAspect="1"/>
+          </p:cNvPicPr>
+          <p:nvPr/>
+        </p:nvPicPr>
+        <p:blipFill>
+          <a:blip r:embed="rId3"/>
+          <a:stretch>
+            <a:fillRect/>
+          </a:stretch>
+        </p:blipFill>
+        <p:spPr>
+          <a:xfrm>
+            <a:off x="8366760" y="4526280"/>
+            <a:ext cx="411480" cy="411480"/>
+          </a:xfrm>
+          <a:prstGeom prst="ellipse">
+            <a:avLst/>
+          </a:prstGeom>
+        </p:spPr>
+      </p:pic>
+      <p:sp>
+        <p:nvSpPr>
+          <p:cNvPr id="5" name="Text 2"/>
+          <p:cNvSpPr/>
+          <p:nvPr/>
+        </p:nvSpPr>
+        <p:spPr>
+          <a:xfrm>
+            <a:off x="640080" y="1481328"/>
+            <a:ext cx="2926080" cy="274320"/>
+          </a:xfrm>
+          <a:prstGeom prst="rect">
+            <a:avLst/>
+          </a:prstGeom>
+          <a:noFill/>
+          <a:ln/>
+        </p:spPr>
+        <p:txBody>
+          <a:bodyPr wrap="square" rtlCol="0" anchor="ctr"/>
+          <a:lstStyle/>
+          <a:p>
+            <a:pPr marL="0" indent="0">
+              <a:buNone/>
+            </a:pPr>
+            <a:r>
+              <a:rPr lang="en-US" sz="1000" b="1" kern="0" spc="100" dirty="0">
+                <a:solidFill>
+                  <a:srgbClr val="6E6389"/>
+                </a:solidFill>
+                <a:latin typeface="Calibri" pitchFamily="34" charset="0"/>
+                <a:ea typeface="Calibri" pitchFamily="34" charset="-122"/>
+                <a:cs typeface="Calibri" pitchFamily="34" charset="-120"/>
+              </a:rPr>
+              <a:t>WHAT YOU WANT</a:t>
+            </a:r>
+            <a:endParaRPr lang="en-US" sz="1000" dirty="0"/>
+          </a:p>
+        </p:txBody>
+      </p:sp>
+      <p:sp>
+        <p:nvSpPr>
+          <p:cNvPr id="6" name="Text 3"/>
+          <p:cNvSpPr/>
+          <p:nvPr/>
+        </p:nvSpPr>
+        <p:spPr>
+          <a:xfrm>
+            <a:off x="3749040" y="1481328"/>
+            <a:ext cx="2468880" cy="274320"/>
+          </a:xfrm>
+          <a:prstGeom prst="rect">
+            <a:avLst/>
+          </a:prstGeom>
+          <a:noFill/>
+          <a:ln/>
+        </p:spPr>
+        <p:txBody>
+          <a:bodyPr wrap="square" rtlCol="0" anchor="ctr"/>
+          <a:lstStyle/>
+          <a:p>
+            <a:pPr marL="0" indent="0">
+              <a:buNone/>
+            </a:pPr>
+            <a:r>
+              <a:rPr lang="en-US" sz="1000" b="1" kern="0" spc="100" dirty="0">
+                <a:solidFill>
+                  <a:srgbClr val="F59E0B"/>
+                </a:solidFill>
+                <a:latin typeface="Calibri" pitchFamily="34" charset="0"/>
+                <a:ea typeface="Calibri" pitchFamily="34" charset="-122"/>
+                <a:cs typeface="Calibri" pitchFamily="34" charset="-120"/>
+              </a:rPr>
+              <a:t>CLAUDE CODE</a:t>
+            </a:r>
+            <a:endParaRPr lang="en-US" sz="1000" dirty="0"/>
+          </a:p>
+        </p:txBody>
+      </p:sp>
+      <p:sp>
+        <p:nvSpPr>
+          <p:cNvPr id="7" name="Text 4"/>
+          <p:cNvSpPr/>
+          <p:nvPr/>
+        </p:nvSpPr>
+        <p:spPr>
+          <a:xfrm>
+            <a:off x="6355080" y="1481328"/>
+            <a:ext cx="2286000" cy="274320"/>
+          </a:xfrm>
+          <a:prstGeom prst="rect">
+            <a:avLst/>
+          </a:prstGeom>
+          <a:noFill/>
+          <a:ln/>
+        </p:spPr>
+        <p:txBody>
+          <a:bodyPr wrap="square" rtlCol="0" anchor="ctr"/>
+          <a:lstStyle/>
+          <a:p>
+            <a:pPr marL="0" indent="0">
+              <a:buNone/>
+            </a:pPr>
+            <a:r>
+              <a:rPr lang="en-US" sz="1000" b="1" kern="0" spc="100" dirty="0">
+                <a:solidFill>
+                  <a:srgbClr val="7C3AED"/>
+                </a:solidFill>
+                <a:latin typeface="Calibri" pitchFamily="34" charset="0"/>
+                <a:ea typeface="Calibri" pitchFamily="34" charset="-122"/>
+                <a:cs typeface="Calibri" pitchFamily="34" charset="-120"/>
+              </a:rPr>
+              <a:t>CODEX</a:t>
+            </a:r>
+            <a:endParaRPr lang="en-US" sz="1000" dirty="0"/>
+          </a:p>
+        </p:txBody>
+      </p:sp>
+      <p:sp>
+        <p:nvSpPr>
+          <p:cNvPr id="8" name="Shape 5"/>
+          <p:cNvSpPr/>
+          <p:nvPr/>
+        </p:nvSpPr>
+        <p:spPr>
+          <a:xfrm>
+            <a:off x="457200" y="1810512"/>
+            <a:ext cx="8229600" cy="603504"/>
+          </a:xfrm>
+          <a:prstGeom prst="rect">
+            <a:avLst/>
+          </a:prstGeom>
+          <a:solidFill>
+            <a:srgbClr val="DDD6FE"/>
+          </a:solidFill>
+          <a:ln/>
+        </p:spPr>
+        <p:txBody>
+          <a:bodyPr/>
+          <a:lstStyle/>
+          <a:p>
+            <a:endParaRPr lang="en-AU"/>
+          </a:p>
+        </p:txBody>
+      </p:sp>
+      <p:sp>
+        <p:nvSpPr>
+          <p:cNvPr id="9" name="Text 6"/>
+          <p:cNvSpPr/>
+          <p:nvPr/>
+        </p:nvSpPr>
+        <p:spPr>
+          <a:xfrm>
+            <a:off x="640080" y="1810512"/>
+            <a:ext cx="3017520" cy="603504"/>
+          </a:xfrm>
+          <a:prstGeom prst="rect">
+            <a:avLst/>
+          </a:prstGeom>
+          <a:noFill/>
+          <a:ln/>
+        </p:spPr>
+        <p:txBody>
+          <a:bodyPr wrap="square" rtlCol="0" anchor="ctr"/>
+          <a:lstStyle/>
+          <a:p>
+            <a:pPr marL="0" indent="0">
+              <a:buNone/>
+            </a:pPr>
+            <a:r>
+              <a:rPr lang="en-US" sz="1250" dirty="0">
+                <a:solidFill>
+                  <a:srgbClr val="2D1155"/>
+                </a:solidFill>
+                <a:latin typeface="Calibri" pitchFamily="34" charset="0"/>
+                <a:ea typeface="Calibri" pitchFamily="34" charset="-122"/>
+                <a:cs typeface="Calibri" pitchFamily="34" charset="-120"/>
+              </a:rPr>
+              <a:t>Check what it's carrying</a:t>
+            </a:r>
+            <a:endParaRPr lang="en-US" sz="1250" dirty="0"/>
+          </a:p>
+        </p:txBody>
+      </p:sp>
+      <p:sp>
+        <p:nvSpPr>
+          <p:cNvPr id="10" name="Text 7"/>
+          <p:cNvSpPr/>
+          <p:nvPr/>
+        </p:nvSpPr>
+        <p:spPr>
+          <a:xfrm>
+            <a:off x="3749040" y="1810512"/>
+            <a:ext cx="2560320" cy="603504"/>
+          </a:xfrm>
+          <a:prstGeom prst="rect">
+            <a:avLst/>
+          </a:prstGeom>
+          <a:noFill/>
+          <a:ln/>
+        </p:spPr>
+        <p:txBody>
+          <a:bodyPr wrap="square" rtlCol="0" anchor="ctr"/>
+          <a:lstStyle/>
+          <a:p>
+            <a:pPr marL="0" indent="0">
+              <a:buNone/>
+            </a:pPr>
+            <a:r>
+              <a:rPr lang="en-US" sz="1300" b="1" dirty="0">
+                <a:solidFill>
+                  <a:srgbClr val="5B21B6"/>
+                </a:solidFill>
+                <a:latin typeface="Courier New" pitchFamily="34" charset="0"/>
+                <a:ea typeface="Courier New" pitchFamily="34" charset="-122"/>
+                <a:cs typeface="Courier New" pitchFamily="34" charset="-120"/>
+              </a:rPr>
+              <a:t>/context</a:t>
+            </a:r>
+            <a:endParaRPr lang="en-US" sz="1300" dirty="0"/>
+          </a:p>
+        </p:txBody>
+      </p:sp>
+      <p:sp>
+        <p:nvSpPr>
+          <p:cNvPr id="11" name="Text 8"/>
+          <p:cNvSpPr/>
+          <p:nvPr/>
+        </p:nvSpPr>
+        <p:spPr>
+          <a:xfrm>
+            <a:off x="6355080" y="1810512"/>
+            <a:ext cx="2286000" cy="603504"/>
+          </a:xfrm>
+          <a:prstGeom prst="rect">
+            <a:avLst/>
+          </a:prstGeom>
+          <a:noFill/>
+          <a:ln/>
+        </p:spPr>
+        <p:txBody>
+          <a:bodyPr wrap="square" rtlCol="0" anchor="ctr"/>
+          <a:lstStyle/>
+          <a:p>
+            <a:pPr marL="0" indent="0">
+              <a:buNone/>
+            </a:pPr>
+            <a:r>
+              <a:rPr lang="en-US" sz="1300" b="1" dirty="0">
+                <a:solidFill>
+                  <a:srgbClr val="7C3AED"/>
+                </a:solidFill>
+                <a:latin typeface="Courier New" pitchFamily="34" charset="0"/>
+                <a:ea typeface="Courier New" pitchFamily="34" charset="-122"/>
+                <a:cs typeface="Courier New" pitchFamily="34" charset="-120"/>
+              </a:rPr>
+              <a:t>/status</a:t>
+            </a:r>
+            <a:endParaRPr lang="en-US" sz="1300" dirty="0"/>
+          </a:p>
+        </p:txBody>
+      </p:sp>
+      <p:sp>
+        <p:nvSpPr>
+          <p:cNvPr id="12" name="Shape 9"/>
+          <p:cNvSpPr/>
+          <p:nvPr/>
+        </p:nvSpPr>
+        <p:spPr>
+          <a:xfrm>
+            <a:off x="457200" y="2414016"/>
+            <a:ext cx="8229600" cy="603504"/>
+          </a:xfrm>
+          <a:prstGeom prst="rect">
+            <a:avLst/>
+          </a:prstGeom>
+          <a:solidFill>
+            <a:srgbClr val="FFFFFF"/>
+          </a:solidFill>
+          <a:ln/>
+        </p:spPr>
+        <p:txBody>
+          <a:bodyPr/>
+          <a:lstStyle/>
+          <a:p>
+            <a:endParaRPr lang="en-AU"/>
+          </a:p>
+        </p:txBody>
+      </p:sp>
+      <p:sp>
+        <p:nvSpPr>
+          <p:cNvPr id="13" name="Text 10"/>
+          <p:cNvSpPr/>
+          <p:nvPr/>
+        </p:nvSpPr>
+        <p:spPr>
+          <a:xfrm>
+            <a:off x="640080" y="2414016"/>
+            <a:ext cx="3017520" cy="603504"/>
+          </a:xfrm>
+          <a:prstGeom prst="rect">
+            <a:avLst/>
+          </a:prstGeom>
+          <a:noFill/>
+          <a:ln/>
+        </p:spPr>
+        <p:txBody>
+          <a:bodyPr wrap="square" rtlCol="0" anchor="ctr"/>
+          <a:lstStyle/>
+          <a:p>
+            <a:pPr marL="0" indent="0">
+              <a:buNone/>
+            </a:pPr>
+            <a:r>
+              <a:rPr lang="en-US" sz="1250" dirty="0">
+                <a:solidFill>
+                  <a:srgbClr val="2D1155"/>
+                </a:solidFill>
+                <a:latin typeface="Calibri" pitchFamily="34" charset="0"/>
+                <a:ea typeface="Calibri" pitchFamily="34" charset="-122"/>
+                <a:cs typeface="Calibri" pitchFamily="34" charset="-120"/>
+              </a:rPr>
+              <a:t>Pin a file into context</a:t>
+            </a:r>
+            <a:endParaRPr lang="en-US" sz="1250" dirty="0"/>
+          </a:p>
+        </p:txBody>
+      </p:sp>
+      <p:sp>
+        <p:nvSpPr>
+          <p:cNvPr id="14" name="Text 11"/>
+          <p:cNvSpPr/>
+          <p:nvPr/>
+        </p:nvSpPr>
+        <p:spPr>
+          <a:xfrm>
+            <a:off x="3749040" y="2414016"/>
+            <a:ext cx="2560320" cy="603504"/>
+          </a:xfrm>
+          <a:prstGeom prst="rect">
+            <a:avLst/>
+          </a:prstGeom>
+          <a:noFill/>
+          <a:ln/>
+        </p:spPr>
+        <p:txBody>
+          <a:bodyPr wrap="square" rtlCol="0" anchor="ctr"/>
+          <a:lstStyle/>
+          <a:p>
+            <a:pPr marL="0" indent="0">
+              <a:buNone/>
+            </a:pPr>
+            <a:r>
+              <a:rPr lang="en-US" sz="1300" b="1" dirty="0">
+                <a:solidFill>
+                  <a:srgbClr val="5B21B6"/>
+                </a:solidFill>
+                <a:latin typeface="Courier New" pitchFamily="34" charset="0"/>
+                <a:ea typeface="Courier New" pitchFamily="34" charset="-122"/>
+                <a:cs typeface="Courier New" pitchFamily="34" charset="-120"/>
+              </a:rPr>
+              <a:t>@path/to/file</a:t>
+            </a:r>
+            <a:endParaRPr lang="en-US" sz="1300" dirty="0"/>
+          </a:p>
+        </p:txBody>
+      </p:sp>
+      <p:sp>
+        <p:nvSpPr>
+          <p:cNvPr id="15" name="Text 12"/>
+          <p:cNvSpPr/>
+          <p:nvPr/>
+        </p:nvSpPr>
+        <p:spPr>
+          <a:xfrm>
+            <a:off x="6355080" y="2414016"/>
+            <a:ext cx="2286000" cy="603504"/>
+          </a:xfrm>
+          <a:prstGeom prst="rect">
+            <a:avLst/>
+          </a:prstGeom>
+          <a:noFill/>
+          <a:ln/>
+        </p:spPr>
+        <p:txBody>
+          <a:bodyPr wrap="square" rtlCol="0" anchor="ctr"/>
+          <a:lstStyle/>
+          <a:p>
+            <a:pPr marL="0" indent="0">
+              <a:buNone/>
+            </a:pPr>
+            <a:r>
+              <a:rPr lang="en-US" sz="1300" b="1" dirty="0">
+                <a:solidFill>
+                  <a:srgbClr val="7C3AED"/>
+                </a:solidFill>
+                <a:latin typeface="Courier New" pitchFamily="34" charset="0"/>
+                <a:ea typeface="Courier New" pitchFamily="34" charset="-122"/>
+                <a:cs typeface="Courier New" pitchFamily="34" charset="-120"/>
+              </a:rPr>
+              <a:t>@path/to/file</a:t>
+            </a:r>
+            <a:endParaRPr lang="en-US" sz="1300" dirty="0"/>
+          </a:p>
+        </p:txBody>
+      </p:sp>
+      <p:sp>
+        <p:nvSpPr>
+          <p:cNvPr id="16" name="Shape 13"/>
+          <p:cNvSpPr/>
+          <p:nvPr/>
+        </p:nvSpPr>
+        <p:spPr>
+          <a:xfrm>
+            <a:off x="457200" y="3017520"/>
+            <a:ext cx="8229600" cy="603504"/>
+          </a:xfrm>
+          <a:prstGeom prst="rect">
+            <a:avLst/>
+          </a:prstGeom>
+          <a:solidFill>
+            <a:srgbClr val="DDD6FE"/>
+          </a:solidFill>
+          <a:ln/>
+        </p:spPr>
+        <p:txBody>
+          <a:bodyPr/>
+          <a:lstStyle/>
+          <a:p>
+            <a:endParaRPr lang="en-AU"/>
+          </a:p>
+        </p:txBody>
+      </p:sp>
+      <p:sp>
+        <p:nvSpPr>
+          <p:cNvPr id="17" name="Text 14"/>
+          <p:cNvSpPr/>
+          <p:nvPr/>
+        </p:nvSpPr>
+        <p:spPr>
+          <a:xfrm>
+            <a:off x="640080" y="3017520"/>
+            <a:ext cx="3017520" cy="603504"/>
+          </a:xfrm>
+          <a:prstGeom prst="rect">
+            <a:avLst/>
+          </a:prstGeom>
+          <a:noFill/>
+          <a:ln/>
+        </p:spPr>
+        <p:txBody>
+          <a:bodyPr wrap="square" rtlCol="0" anchor="ctr"/>
+          <a:lstStyle/>
+          <a:p>
+            <a:pPr marL="0" indent="0">
+              <a:buNone/>
+            </a:pPr>
+            <a:r>
+              <a:rPr lang="en-US" sz="1250" dirty="0">
+                <a:solidFill>
+                  <a:srgbClr val="2D1155"/>
+                </a:solidFill>
+                <a:latin typeface="Calibri" pitchFamily="34" charset="0"/>
+                <a:ea typeface="Calibri" pitchFamily="34" charset="-122"/>
+                <a:cs typeface="Calibri" pitchFamily="34" charset="-120"/>
+              </a:rPr>
+              <a:t>Trim a bloated context</a:t>
+            </a:r>
+            <a:endParaRPr lang="en-US" sz="1250" dirty="0"/>
+          </a:p>
+        </p:txBody>
+      </p:sp>
+      <p:sp>
+        <p:nvSpPr>
+          <p:cNvPr id="18" name="Text 15"/>
+          <p:cNvSpPr/>
+          <p:nvPr/>
+        </p:nvSpPr>
+        <p:spPr>
+          <a:xfrm>
+            <a:off x="3749040" y="3017520"/>
+            <a:ext cx="2560320" cy="603504"/>
+          </a:xfrm>
+          <a:prstGeom prst="rect">
+            <a:avLst/>
+          </a:prstGeom>
+          <a:noFill/>
+          <a:ln/>
+        </p:spPr>
+        <p:txBody>
+          <a:bodyPr wrap="square" rtlCol="0" anchor="ctr"/>
+          <a:lstStyle/>
+          <a:p>
+            <a:pPr marL="0" indent="0">
+              <a:buNone/>
+            </a:pPr>
+            <a:r>
+              <a:rPr lang="en-US" sz="1300" b="1" dirty="0">
+                <a:solidFill>
+                  <a:srgbClr val="5B21B6"/>
+                </a:solidFill>
+                <a:latin typeface="Courier New" pitchFamily="34" charset="0"/>
+                <a:ea typeface="Courier New" pitchFamily="34" charset="-122"/>
+                <a:cs typeface="Courier New" pitchFamily="34" charset="-120"/>
+              </a:rPr>
+              <a:t>/compact</a:t>
+            </a:r>
+            <a:endParaRPr lang="en-US" sz="1300" dirty="0"/>
+          </a:p>
+        </p:txBody>
+      </p:sp>
+      <p:sp>
+        <p:nvSpPr>
+          <p:cNvPr id="19" name="Text 16"/>
+          <p:cNvSpPr/>
+          <p:nvPr/>
+        </p:nvSpPr>
+        <p:spPr>
+          <a:xfrm>
+            <a:off x="6355080" y="3017520"/>
+            <a:ext cx="2286000" cy="603504"/>
+          </a:xfrm>
+          <a:prstGeom prst="rect">
+            <a:avLst/>
+          </a:prstGeom>
+          <a:noFill/>
+          <a:ln/>
+        </p:spPr>
+        <p:txBody>
+          <a:bodyPr wrap="square" rtlCol="0" anchor="ctr"/>
+          <a:lstStyle/>
+          <a:p>
+            <a:pPr marL="0" indent="0">
+              <a:buNone/>
+            </a:pPr>
+            <a:r>
+              <a:rPr lang="en-US" sz="1300" b="1" dirty="0">
+                <a:solidFill>
+                  <a:srgbClr val="7C3AED"/>
+                </a:solidFill>
+                <a:latin typeface="Courier New" pitchFamily="34" charset="0"/>
+                <a:ea typeface="Courier New" pitchFamily="34" charset="-122"/>
+                <a:cs typeface="Courier New" pitchFamily="34" charset="-120"/>
+              </a:rPr>
+              <a:t>/compact</a:t>
+            </a:r>
+            <a:endParaRPr lang="en-US" sz="1300" dirty="0"/>
+          </a:p>
+        </p:txBody>
+      </p:sp>
+      <p:sp>
+        <p:nvSpPr>
+          <p:cNvPr id="20" name="Shape 17"/>
+          <p:cNvSpPr/>
+          <p:nvPr/>
+        </p:nvSpPr>
+        <p:spPr>
+          <a:xfrm>
+            <a:off x="457200" y="3621024"/>
+            <a:ext cx="8229600" cy="603504"/>
+          </a:xfrm>
+          <a:prstGeom prst="rect">
+            <a:avLst/>
+          </a:prstGeom>
+          <a:solidFill>
+            <a:srgbClr val="FFFFFF"/>
+          </a:solidFill>
+          <a:ln/>
+        </p:spPr>
+        <p:txBody>
+          <a:bodyPr/>
+          <a:lstStyle/>
+          <a:p>
+            <a:endParaRPr lang="en-AU"/>
+          </a:p>
+        </p:txBody>
+      </p:sp>
+      <p:sp>
+        <p:nvSpPr>
+          <p:cNvPr id="21" name="Text 18"/>
+          <p:cNvSpPr/>
+          <p:nvPr/>
+        </p:nvSpPr>
+        <p:spPr>
+          <a:xfrm>
+            <a:off x="640080" y="3621024"/>
+            <a:ext cx="3017520" cy="603504"/>
+          </a:xfrm>
+          <a:prstGeom prst="rect">
+            <a:avLst/>
+          </a:prstGeom>
+          <a:noFill/>
+          <a:ln/>
+        </p:spPr>
+        <p:txBody>
+          <a:bodyPr wrap="square" rtlCol="0" anchor="ctr"/>
+          <a:lstStyle/>
+          <a:p>
+            <a:pPr marL="0" indent="0">
+              <a:buNone/>
+            </a:pPr>
+            <a:r>
+              <a:rPr lang="en-US" sz="1250" dirty="0">
+                <a:solidFill>
+                  <a:srgbClr val="2D1155"/>
+                </a:solidFill>
+                <a:latin typeface="Calibri" pitchFamily="34" charset="0"/>
+                <a:ea typeface="Calibri" pitchFamily="34" charset="-122"/>
+                <a:cs typeface="Calibri" pitchFamily="34" charset="-120"/>
+              </a:rPr>
+              <a:t>Start fresh</a:t>
+            </a:r>
+            <a:endParaRPr lang="en-US" sz="1250" dirty="0"/>
+          </a:p>
+        </p:txBody>
+      </p:sp>
+      <p:sp>
+        <p:nvSpPr>
+          <p:cNvPr id="22" name="Text 19"/>
+          <p:cNvSpPr/>
+          <p:nvPr/>
+        </p:nvSpPr>
+        <p:spPr>
+          <a:xfrm>
+            <a:off x="3749040" y="3621024"/>
+            <a:ext cx="2560320" cy="603504"/>
+          </a:xfrm>
+          <a:prstGeom prst="rect">
+            <a:avLst/>
+          </a:prstGeom>
+          <a:noFill/>
+          <a:ln/>
+        </p:spPr>
+        <p:txBody>
+          <a:bodyPr wrap="square" rtlCol="0" anchor="ctr"/>
+          <a:lstStyle/>
+          <a:p>
+            <a:pPr marL="0" indent="0">
+              <a:buNone/>
+            </a:pPr>
+            <a:r>
+              <a:rPr lang="en-US" sz="1300" b="1" dirty="0">
+                <a:solidFill>
+                  <a:srgbClr val="5B21B6"/>
+                </a:solidFill>
+                <a:latin typeface="Courier New" pitchFamily="34" charset="0"/>
+                <a:ea typeface="Courier New" pitchFamily="34" charset="-122"/>
+                <a:cs typeface="Courier New" pitchFamily="34" charset="-120"/>
+              </a:rPr>
+              <a:t>/clear</a:t>
+            </a:r>
+            <a:endParaRPr lang="en-US" sz="1300" dirty="0"/>
+          </a:p>
+        </p:txBody>
+      </p:sp>
+      <p:sp>
+        <p:nvSpPr>
+          <p:cNvPr id="23" name="Text 20"/>
+          <p:cNvSpPr/>
+          <p:nvPr/>
+        </p:nvSpPr>
+        <p:spPr>
+          <a:xfrm>
+            <a:off x="6355080" y="3621024"/>
+            <a:ext cx="2286000" cy="603504"/>
+          </a:xfrm>
+          <a:prstGeom prst="rect">
+            <a:avLst/>
+          </a:prstGeom>
+          <a:noFill/>
+          <a:ln/>
+        </p:spPr>
+        <p:txBody>
+          <a:bodyPr wrap="square" rtlCol="0" anchor="ctr"/>
+          <a:lstStyle/>
+          <a:p>
+            <a:pPr marL="0" indent="0">
+              <a:buNone/>
+            </a:pPr>
+            <a:r>
+              <a:rPr lang="en-US" sz="1300" b="1" dirty="0">
+                <a:solidFill>
+                  <a:srgbClr val="7C3AED"/>
+                </a:solidFill>
+                <a:latin typeface="Courier New" pitchFamily="34" charset="0"/>
+                <a:ea typeface="Courier New" pitchFamily="34" charset="-122"/>
+                <a:cs typeface="Courier New" pitchFamily="34" charset="-120"/>
+              </a:rPr>
+              <a:t>new session</a:t>
+            </a:r>
+            <a:endParaRPr lang="en-US" sz="1300" dirty="0"/>
+          </a:p>
+        </p:txBody>
+      </p:sp>
+      <p:sp>
+        <p:nvSpPr>
+          <p:cNvPr id="24" name="Text 21"/>
+          <p:cNvSpPr/>
+          <p:nvPr/>
+        </p:nvSpPr>
+        <p:spPr>
+          <a:xfrm>
+            <a:off x="457200" y="4370832"/>
+            <a:ext cx="8229600" cy="320040"/>
+          </a:xfrm>
+          <a:prstGeom prst="rect">
+            <a:avLst/>
+          </a:prstGeom>
+          <a:noFill/>
+          <a:ln/>
+        </p:spPr>
+        <p:txBody>
+          <a:bodyPr wrap="square" rtlCol="0" anchor="ctr"/>
+          <a:lstStyle/>
+          <a:p>
+            <a:pPr marL="0" indent="0">
+              <a:buNone/>
+            </a:pPr>
+            <a:r>
+              <a:rPr lang="en-US" sz="1150" i="1" dirty="0">
+                <a:solidFill>
+                  <a:srgbClr val="6E6389"/>
+                </a:solidFill>
+                <a:latin typeface="Calibri" pitchFamily="34" charset="0"/>
+                <a:ea typeface="Calibri" pitchFamily="34" charset="-122"/>
+                <a:cs typeface="Calibri" pitchFamily="34" charset="-120"/>
+              </a:rPr>
+              <a:t>You don't need to memorise these — just know they exist and reach for them when answers go vague.</a:t>
+            </a:r>
+            <a:endParaRPr lang="en-US" sz="1150" dirty="0"/>
           </a:p>
         </p:txBody>
       </p:sp>

</xml_diff>